<commit_message>
Add agentic SQL generation and schema retrieval
</commit_message>
<xml_diff>
--- a/presentation/autonomous_ai_agents_case_presentation_final.pptx
+++ b/presentation/autonomous_ai_agents_case_presentation_final.pptx
@@ -5,14 +5,13 @@
     <p:sldMasterId id="2147483648" r:id="rId1"/>
   </p:sldMasterIdLst>
   <p:notesMasterIdLst>
-    <p:notesMasterId r:id="rId7"/>
+    <p:notesMasterId r:id="rId6"/>
   </p:notesMasterIdLst>
   <p:sldIdLst>
     <p:sldId id="256" r:id="rId2"/>
     <p:sldId id="257" r:id="rId3"/>
     <p:sldId id="258" r:id="rId4"/>
     <p:sldId id="259" r:id="rId5"/>
-    <p:sldId id="260" r:id="rId6"/>
   </p:sldIdLst>
   <p:sldSz cx="12192000" cy="6858000"/>
   <p:notesSz cx="6858000" cy="9144000"/>
@@ -334,155 +333,7 @@
           <a:bodyPr/>
           <a:lstStyle/>
           <a:p>
-            <a:r>
-              <a:t>Simple talk track, about 60 seconds.</a:t>
-            </a:r>
-          </a:p>
-          <a:p>
-            <a:endParaRPr/>
-          </a:p>
-          <a:p>
-            <a:r>
-              <a:t>Opening:</a:t>
-            </a:r>
-          </a:p>
-          <a:p>
-            <a:r>
-              <a:t>I built a working two-agent analytics system for the case.</a:t>
-            </a:r>
-          </a:p>
-          <a:p>
-            <a:r>
-              <a:t>The goal was not only to call an LLM.</a:t>
-            </a:r>
-          </a:p>
-          <a:p>
-            <a:r>
-              <a:t>The goal was to make the analysis safe, controlled, visual, and testable.</a:t>
-            </a:r>
-          </a:p>
-          <a:p>
-            <a:endParaRPr/>
-          </a:p>
-          <a:p>
-            <a:r>
-              <a:t>Bullet 1 - Ask -&gt; safe SQL:</a:t>
-            </a:r>
-          </a:p>
-          <a:p>
-            <a:r>
-              <a:t>A user can ask a data question in the UI or CLI.</a:t>
-            </a:r>
-          </a:p>
-          <a:p>
-            <a:r>
-              <a:t>The Data Analysis Agent turns the question into SQL.</a:t>
-            </a:r>
-          </a:p>
-          <a:p>
-            <a:r>
-              <a:t>Before running the SQL, the system checks that it is safe.</a:t>
-            </a:r>
-          </a:p>
-          <a:p>
-            <a:r>
-              <a:t>Only read-only SELECT style queries are allowed.</a:t>
-            </a:r>
-          </a:p>
-          <a:p>
-            <a:endParaRPr/>
-          </a:p>
-          <a:p>
-            <a:r>
-              <a:t>Bullet 2 - Analyze -&gt; styled charts:</a:t>
-            </a:r>
-          </a:p>
-          <a:p>
-            <a:r>
-              <a:t>After the query runs, the result is stored as an AnalysisResult.</a:t>
-            </a:r>
-          </a:p>
-          <a:p>
-            <a:r>
-              <a:t>The Data Visualization Agent uses that result.</a:t>
-            </a:r>
-          </a:p>
-          <a:p>
-            <a:r>
-              <a:t>It creates a chart and CSV output in the company style.</a:t>
-            </a:r>
-          </a:p>
-          <a:p>
-            <a:endParaRPr/>
-          </a:p>
-          <a:p>
-            <a:r>
-              <a:t>Bullet 3 - Role-based access:</a:t>
-            </a:r>
-          </a:p>
-          <a:p>
-            <a:r>
-              <a:t>Users do not all see the same databases.</a:t>
-            </a:r>
-          </a:p>
-          <a:p>
-            <a:r>
-              <a:t>For example, bob can only access sakila.</a:t>
-            </a:r>
-          </a:p>
-          <a:p>
-            <a:r>
-              <a:t>This shows the user restriction requirement.</a:t>
-            </a:r>
-          </a:p>
-          <a:p>
-            <a:endParaRPr/>
-          </a:p>
-          <a:p>
-            <a:r>
-              <a:t>Bullet 4 - Add DBs via UI/CLI:</a:t>
-            </a:r>
-          </a:p>
-          <a:p>
-            <a:r>
-              <a:t>I added a straightforward database integration path.</a:t>
-            </a:r>
-          </a:p>
-          <a:p>
-            <a:r>
-              <a:t>Admin can add a SQLite database from Streamlit or from the CLI.</a:t>
-            </a:r>
-          </a:p>
-          <a:p>
-            <a:r>
-              <a:t>The new database can then be granted to selected users.</a:t>
-            </a:r>
-          </a:p>
-          <a:p>
-            <a:endParaRPr/>
-          </a:p>
-          <a:p>
-            <a:r>
-              <a:t>Transition:</a:t>
-            </a:r>
-          </a:p>
-          <a:p>
-            <a:r>
-              <a:t>Next, I will show how the system is connected internally.</a:t>
-            </a:r>
-          </a:p>
-          <a:p>
-            <a:endParaRPr/>
-          </a:p>
-          <a:p>
-            <a:r>
-              <a:t>[Sources]</a:t>
-            </a:r>
-          </a:p>
-          <a:p>
-            <a:r>
-              <a:t>- Local project source code and README in C:/Users/win11/PycharmProjects/autonomous-ai-data-agents.</a:t>
-            </a:r>
+            <a:endParaRPr dirty="0"/>
           </a:p>
         </p:txBody>
       </p:sp>
@@ -557,211 +408,7 @@
           <a:bodyPr/>
           <a:lstStyle/>
           <a:p>
-            <a:r>
-              <a:t>Simple talk track, about 75 seconds.</a:t>
-            </a:r>
-          </a:p>
-          <a:p>
-            <a:endParaRPr/>
-          </a:p>
-          <a:p>
-            <a:r>
-              <a:t>Opening:</a:t>
-            </a:r>
-          </a:p>
-          <a:p>
-            <a:r>
-              <a:t>This slide shows the real architecture from the code.</a:t>
-            </a:r>
-          </a:p>
-          <a:p>
-            <a:r>
-              <a:t>The main point is that the two agents work together through one result object.</a:t>
-            </a:r>
-          </a:p>
-          <a:p>
-            <a:endParaRPr/>
-          </a:p>
-          <a:p>
-            <a:r>
-              <a:t>Entry points:</a:t>
-            </a:r>
-          </a:p>
-          <a:p>
-            <a:r>
-              <a:t>The user can start from Streamlit or from the CLI.</a:t>
-            </a:r>
-          </a:p>
-          <a:p>
-            <a:r>
-              <a:t>Both entry points call the same AgentOrchestrator.</a:t>
-            </a:r>
-          </a:p>
-          <a:p>
-            <a:r>
-              <a:t>This keeps the behavior consistent.</a:t>
-            </a:r>
-          </a:p>
-          <a:p>
-            <a:endParaRPr/>
-          </a:p>
-          <a:p>
-            <a:r>
-              <a:t>Control layer:</a:t>
-            </a:r>
-          </a:p>
-          <a:p>
-            <a:r>
-              <a:t>The orchestrator is the central coordinator.</a:t>
-            </a:r>
-          </a:p>
-          <a:p>
-            <a:r>
-              <a:t>It checks user access with AccessControl.</a:t>
-            </a:r>
-          </a:p>
-          <a:p>
-            <a:r>
-              <a:t>It finds the correct SQLite file with DatabaseRegistry.</a:t>
-            </a:r>
-          </a:p>
-          <a:p>
-            <a:r>
-              <a:t>DatabaseRegistry can also add or update database entries from the CLI or admin UI.</a:t>
-            </a:r>
-          </a:p>
-          <a:p>
-            <a:r>
-              <a:t>Then it starts the analysis step.</a:t>
-            </a:r>
-          </a:p>
-          <a:p>
-            <a:endParaRPr/>
-          </a:p>
-          <a:p>
-            <a:r>
-              <a:t>Data Analysis Agent:</a:t>
-            </a:r>
-          </a:p>
-          <a:p>
-            <a:r>
-              <a:t>This agent receives the question and the selected database.</a:t>
-            </a:r>
-          </a:p>
-          <a:p>
-            <a:r>
-              <a:t>It reads the database schema.</a:t>
-            </a:r>
-          </a:p>
-          <a:p>
-            <a:r>
-              <a:t>It generates SQL using OpenAI or an exact offline template.</a:t>
-            </a:r>
-          </a:p>
-          <a:p>
-            <a:r>
-              <a:t>It validates the SQL and runs it through a read-only SQLite connection.</a:t>
-            </a:r>
-          </a:p>
-          <a:p>
-            <a:endParaRPr/>
-          </a:p>
-          <a:p>
-            <a:r>
-              <a:t>Handoff object:</a:t>
-            </a:r>
-          </a:p>
-          <a:p>
-            <a:r>
-              <a:t>The output of the analysis step is AnalysisResult.</a:t>
-            </a:r>
-          </a:p>
-          <a:p>
-            <a:r>
-              <a:t>It contains the SQL, summary, DataFrame, and metadata.</a:t>
-            </a:r>
-          </a:p>
-          <a:p>
-            <a:r>
-              <a:t>This is the contract between the two agents.</a:t>
-            </a:r>
-          </a:p>
-          <a:p>
-            <a:endParaRPr/>
-          </a:p>
-          <a:p>
-            <a:r>
-              <a:t>Data Visualization Agent:</a:t>
-            </a:r>
-          </a:p>
-          <a:p>
-            <a:r>
-              <a:t>The visualization agent does not query the database again.</a:t>
-            </a:r>
-          </a:p>
-          <a:p>
-            <a:r>
-              <a:t>It receives AnalysisResult from the analysis agent.</a:t>
-            </a:r>
-          </a:p>
-          <a:p>
-            <a:r>
-              <a:t>Then it creates the chart and CSV file using the company style.</a:t>
-            </a:r>
-          </a:p>
-          <a:p>
-            <a:endParaRPr/>
-          </a:p>
-          <a:p>
-            <a:r>
-              <a:t>Support modules:</a:t>
-            </a:r>
-          </a:p>
-          <a:p>
-            <a:r>
-              <a:t>SQL generation supports online OpenAI and offline templates.</a:t>
-            </a:r>
-          </a:p>
-          <a:p>
-            <a:r>
-              <a:t>Database onboarding supports Streamlit admin UI, CLI, and YAML configuration.</a:t>
-            </a:r>
-          </a:p>
-          <a:p>
-            <a:r>
-              <a:t>The safe data path includes schema reading, SQL guarding, and read-only SQLite.</a:t>
-            </a:r>
-          </a:p>
-          <a:p>
-            <a:r>
-              <a:t>Chart styling uses ChartFactory and style.yaml.</a:t>
-            </a:r>
-          </a:p>
-          <a:p>
-            <a:endParaRPr/>
-          </a:p>
-          <a:p>
-            <a:r>
-              <a:t>Transition:</a:t>
-            </a:r>
-          </a:p>
-          <a:p>
-            <a:r>
-              <a:t>Now I will explain the design choices behind this architecture.</a:t>
-            </a:r>
-          </a:p>
-          <a:p>
-            <a:endParaRPr/>
-          </a:p>
-          <a:p>
-            <a:r>
-              <a:t>[Sources]</a:t>
-            </a:r>
-          </a:p>
-          <a:p>
-            <a:r>
-              <a:t>- Local project source code and README in C:/Users/win11/PycharmProjects/autonomous-ai-data-agents.</a:t>
-            </a:r>
+            <a:endParaRPr dirty="0"/>
           </a:p>
         </p:txBody>
       </p:sp>
@@ -836,188 +483,7 @@
           <a:bodyPr/>
           <a:lstStyle/>
           <a:p>
-            <a:r>
-              <a:t>Simple talk track, about 60 seconds.</a:t>
-            </a:r>
-          </a:p>
-          <a:p>
-            <a:endParaRPr/>
-          </a:p>
-          <a:p>
-            <a:r>
-              <a:t>Opening:</a:t>
-            </a:r>
-          </a:p>
-          <a:p>
-            <a:r>
-              <a:t>This slide is about my design choices.</a:t>
-            </a:r>
-          </a:p>
-          <a:p>
-            <a:r>
-              <a:t>I wanted the project to feel like a small production-minded MVP.</a:t>
-            </a:r>
-          </a:p>
-          <a:p>
-            <a:endParaRPr/>
-          </a:p>
-          <a:p>
-            <a:r>
-              <a:t>Bullet 1 - System design:</a:t>
-            </a:r>
-          </a:p>
-          <a:p>
-            <a:r>
-              <a:t>I separated the two agents clearly.</a:t>
-            </a:r>
-          </a:p>
-          <a:p>
-            <a:r>
-              <a:t>The analysis agent handles SQL and data.</a:t>
-            </a:r>
-          </a:p>
-          <a:p>
-            <a:r>
-              <a:t>The visualization agent handles charts and files.</a:t>
-            </a:r>
-          </a:p>
-          <a:p>
-            <a:r>
-              <a:t>The orchestrator connects them and controls the flow.</a:t>
-            </a:r>
-          </a:p>
-          <a:p>
-            <a:r>
-              <a:t>This makes the system easier to test and explain.</a:t>
-            </a:r>
-          </a:p>
-          <a:p>
-            <a:endParaRPr/>
-          </a:p>
-          <a:p>
-            <a:r>
-              <a:t>Bullet 2 - Safety mindset:</a:t>
-            </a:r>
-          </a:p>
-          <a:p>
-            <a:r>
-              <a:t>I did not let model-generated SQL run directly.</a:t>
-            </a:r>
-          </a:p>
-          <a:p>
-            <a:r>
-              <a:t>The SQL guard blocks unsafe commands like DROP, DELETE, and UPDATE.</a:t>
-            </a:r>
-          </a:p>
-          <a:p>
-            <a:r>
-              <a:t>The system adds a row limit.</a:t>
-            </a:r>
-          </a:p>
-          <a:p>
-            <a:r>
-              <a:t>SQLite is opened in read-only mode.</a:t>
-            </a:r>
-          </a:p>
-          <a:p>
-            <a:endParaRPr/>
-          </a:p>
-          <a:p>
-            <a:r>
-              <a:t>Bullet 3 - Easy integration:</a:t>
-            </a:r>
-          </a:p>
-          <a:p>
-            <a:r>
-              <a:t>I added a clear path for adding new SQLite databases.</a:t>
-            </a:r>
-          </a:p>
-          <a:p>
-            <a:r>
-              <a:t>Admin can add a database from the Streamlit sidebar or from the CLI.</a:t>
-            </a:r>
-          </a:p>
-          <a:p>
-            <a:r>
-              <a:t>The registry validates the file and writes the database entry to databases.yaml.</a:t>
-            </a:r>
-          </a:p>
-          <a:p>
-            <a:r>
-              <a:t>The database can then be granted to selected users.</a:t>
-            </a:r>
-          </a:p>
-          <a:p>
-            <a:endParaRPr/>
-          </a:p>
-          <a:p>
-            <a:r>
-              <a:t>Bullet 4 - Product control:</a:t>
-            </a:r>
-          </a:p>
-          <a:p>
-            <a:r>
-              <a:t>Users can choose online or offline mode.</a:t>
-            </a:r>
-          </a:p>
-          <a:p>
-            <a:r>
-              <a:t>They can choose chart type, row limit, and preview size.</a:t>
-            </a:r>
-          </a:p>
-          <a:p>
-            <a:r>
-              <a:t>This makes the agents controllable, not hidden.</a:t>
-            </a:r>
-          </a:p>
-          <a:p>
-            <a:endParaRPr/>
-          </a:p>
-          <a:p>
-            <a:r>
-              <a:t>Bullet 5 - Evaluation discipline:</a:t>
-            </a:r>
-          </a:p>
-          <a:p>
-            <a:r>
-              <a:t>I added tests for access, SQL safety, analysis, visualization, and the full pipeline.</a:t>
-            </a:r>
-          </a:p>
-          <a:p>
-            <a:r>
-              <a:t>For agent systems, a demo is not enough.</a:t>
-            </a:r>
-          </a:p>
-          <a:p>
-            <a:r>
-              <a:t>I wanted evidence that the system works in important cases.</a:t>
-            </a:r>
-          </a:p>
-          <a:p>
-            <a:endParaRPr/>
-          </a:p>
-          <a:p>
-            <a:r>
-              <a:t>Transition:</a:t>
-            </a:r>
-          </a:p>
-          <a:p>
-            <a:r>
-              <a:t>Next, I will show how these choices appear in the interface.</a:t>
-            </a:r>
-          </a:p>
-          <a:p>
-            <a:endParaRPr/>
-          </a:p>
-          <a:p>
-            <a:r>
-              <a:t>[Sources]</a:t>
-            </a:r>
-          </a:p>
-          <a:p>
-            <a:r>
-              <a:t>- Local project source code and README in C:/Users/win11/PycharmProjects/autonomous-ai-data-agents.</a:t>
-            </a:r>
+            <a:endParaRPr dirty="0"/>
           </a:p>
         </p:txBody>
       </p:sp>
@@ -1092,498 +558,7 @@
           <a:bodyPr/>
           <a:lstStyle/>
           <a:p>
-            <a:r>
-              <a:t>Simple talk track, about 60 seconds.</a:t>
-            </a:r>
-          </a:p>
-          <a:p>
-            <a:endParaRPr/>
-          </a:p>
-          <a:p>
-            <a:r>
-              <a:t>Opening:</a:t>
-            </a:r>
-          </a:p>
-          <a:p>
-            <a:r>
-              <a:t>The interface is important because it makes the agent pipeline usable.</a:t>
-            </a:r>
-          </a:p>
-          <a:p>
-            <a:r>
-              <a:t>A user should be able to control what the agents do and understand the result.</a:t>
-            </a:r>
-          </a:p>
-          <a:p>
-            <a:endParaRPr/>
-          </a:p>
-          <a:p>
-            <a:r>
-              <a:t>Bullet 1 - Permission-aware:</a:t>
-            </a:r>
-          </a:p>
-          <a:p>
-            <a:r>
-              <a:t>The user first selects or enters a username.</a:t>
-            </a:r>
-          </a:p>
-          <a:p>
-            <a:r>
-              <a:t>The UI only shows databases that this user can access.</a:t>
-            </a:r>
-          </a:p>
-          <a:p>
-            <a:r>
-              <a:t>This prevents users from accidentally querying restricted data.</a:t>
-            </a:r>
-          </a:p>
-          <a:p>
-            <a:endParaRPr/>
-          </a:p>
-          <a:p>
-            <a:r>
-              <a:t>Bullet 2 - Controllable:</a:t>
-            </a:r>
-          </a:p>
-          <a:p>
-            <a:r>
-              <a:t>The user can choose the database.</a:t>
-            </a:r>
-          </a:p>
-          <a:p>
-            <a:r>
-              <a:t>The user can choose online OpenAI mode or offline sample mode.</a:t>
-            </a:r>
-          </a:p>
-          <a:p>
-            <a:r>
-              <a:t>The user can choose chart type, row limit, and preview rows.</a:t>
-            </a:r>
-          </a:p>
-          <a:p>
-            <a:r>
-              <a:t>These controls match the requirement that agents should be controllable.</a:t>
-            </a:r>
-          </a:p>
-          <a:p>
-            <a:endParaRPr/>
-          </a:p>
-          <a:p>
-            <a:r>
-              <a:t>Bullet 3 - Transparent:</a:t>
-            </a:r>
-          </a:p>
-          <a:p>
-            <a:r>
-              <a:t>After analysis, the UI shows what happened step by step.</a:t>
-            </a:r>
-          </a:p>
-          <a:p>
-            <a:r>
-              <a:t>It shows the SQL source, generated SQL, summary, data preview, chart, and saved files.</a:t>
-            </a:r>
-          </a:p>
-          <a:p>
-            <a:r>
-              <a:t>This helps the user trust the result.</a:t>
-            </a:r>
-          </a:p>
-          <a:p>
-            <a:r>
-              <a:t>It also helps me debug the system during the demo.</a:t>
-            </a:r>
-          </a:p>
-          <a:p>
-            <a:endParaRPr/>
-          </a:p>
-          <a:p>
-            <a:r>
-              <a:t>Bullet 4 - Admin-ready:</a:t>
-            </a:r>
-          </a:p>
-          <a:p>
-            <a:r>
-              <a:t>The admin sidebar supports both user management and database management.</a:t>
-            </a:r>
-          </a:p>
-          <a:p>
-            <a:r>
-              <a:t>Admin can add a SQLite file, give it a description, and grant access to users.</a:t>
-            </a:r>
-          </a:p>
-          <a:p>
-            <a:r>
-              <a:t>For newly added databases, the UI disables offline sample behavior and asks the user to type a custom question in Online OpenAI mode.</a:t>
-            </a:r>
-          </a:p>
-          <a:p>
-            <a:endParaRPr/>
-          </a:p>
-          <a:p>
-            <a:r>
-              <a:t>CLI note:</a:t>
-            </a:r>
-          </a:p>
-          <a:p>
-            <a:r>
-              <a:t>The CLI has the same core controls.</a:t>
-            </a:r>
-          </a:p>
-          <a:p>
-            <a:r>
-              <a:t>This is useful for reproducible runs and as a backup during the live demo.</a:t>
-            </a:r>
-          </a:p>
-          <a:p>
-            <a:endParaRPr/>
-          </a:p>
-          <a:p>
-            <a:r>
-              <a:t>Transition:</a:t>
-            </a:r>
-          </a:p>
-          <a:p>
-            <a:r>
-              <a:t>Finally, I will show how I evaluated the system.</a:t>
-            </a:r>
-          </a:p>
-          <a:p>
-            <a:endParaRPr/>
-          </a:p>
-          <a:p>
-            <a:r>
-              <a:t>[Sources]</a:t>
-            </a:r>
-          </a:p>
-          <a:p>
-            <a:r>
-              <a:t>- Local project source code and README in C:/Users/win11/PycharmProjects/autonomous-ai-data-agents.</a:t>
-            </a:r>
-          </a:p>
-        </p:txBody>
-      </p:sp>
-      <p:sp>
-        <p:nvSpPr>
-          <p:cNvPr id="4" name="Slide Number Placeholder 3"/>
-          <p:cNvSpPr>
-            <a:spLocks noGrp="1"/>
-          </p:cNvSpPr>
-          <p:nvPr>
-            <p:ph type="sldNum" idx="5"/>
-          </p:nvPr>
-        </p:nvSpPr>
-        <p:spPr/>
-        <p:txBody>
-          <a:bodyPr/>
-          <a:lstStyle/>
-          <a:p>
-            <a:endParaRPr/>
-          </a:p>
-        </p:txBody>
-      </p:sp>
-    </p:spTree>
-  </p:cSld>
-  <p:clrMapOvr>
-    <a:masterClrMapping/>
-  </p:clrMapOvr>
-</p:notes>
-</file>
-
-<file path=ppt/notesSlides/notesSlide5.xml><?xml version="1.0" encoding="utf-8"?>
-<p:notes xmlns:a="http://schemas.openxmlformats.org/drawingml/2006/main" xmlns:r="http://schemas.openxmlformats.org/officeDocument/2006/relationships" xmlns:p="http://schemas.openxmlformats.org/presentationml/2006/main">
-  <p:cSld>
-    <p:spTree>
-      <p:nvGrpSpPr>
-        <p:cNvPr id="1" name=""/>
-        <p:cNvGrpSpPr/>
-        <p:nvPr/>
-      </p:nvGrpSpPr>
-      <p:grpSpPr>
-        <a:xfrm>
-          <a:off x="0" y="0"/>
-          <a:ext cx="0" cy="0"/>
-          <a:chOff x="0" y="0"/>
-          <a:chExt cx="0" cy="0"/>
-        </a:xfrm>
-      </p:grpSpPr>
-      <p:sp>
-        <p:nvSpPr>
-          <p:cNvPr id="2" name="Slide Image Placeholder 1"/>
-          <p:cNvSpPr>
-            <a:spLocks noGrp="1" noRot="1" noChangeAspect="1"/>
-          </p:cNvSpPr>
-          <p:nvPr>
-            <p:ph type="sldImg"/>
-          </p:nvPr>
-        </p:nvSpPr>
-        <p:spPr/>
-      </p:sp>
-      <p:sp>
-        <p:nvSpPr>
-          <p:cNvPr id="3" name="Notes Placeholder 2"/>
-          <p:cNvSpPr>
-            <a:spLocks noGrp="1"/>
-          </p:cNvSpPr>
-          <p:nvPr>
-            <p:ph type="body" idx="1"/>
-          </p:nvPr>
-        </p:nvSpPr>
-        <p:spPr/>
-        <p:txBody>
-          <a:bodyPr/>
-          <a:lstStyle/>
-          <a:p>
-            <a:r>
-              <a:t>Simple talk track, about 70 seconds.</a:t>
-            </a:r>
-          </a:p>
-          <a:p>
-            <a:endParaRPr/>
-          </a:p>
-          <a:p>
-            <a:r>
-              <a:t>Opening:</a:t>
-            </a:r>
-          </a:p>
-          <a:p>
-            <a:r>
-              <a:t>For evaluation, I focused on the main failure modes of this type of system.</a:t>
-            </a:r>
-          </a:p>
-          <a:p>
-            <a:r>
-              <a:t>The test suite has 20 out of 20 tests passing locally.</a:t>
-            </a:r>
-          </a:p>
-          <a:p>
-            <a:endParaRPr/>
-          </a:p>
-          <a:p>
-            <a:r>
-              <a:t>Bullet 1 - User access:</a:t>
-            </a:r>
-          </a:p>
-          <a:p>
-            <a:r>
-              <a:t>I tested that allowed users can access their databases.</a:t>
-            </a:r>
-          </a:p>
-          <a:p>
-            <a:r>
-              <a:t>I tested that blocked users cannot access restricted databases.</a:t>
-            </a:r>
-          </a:p>
-          <a:p>
-            <a:r>
-              <a:t>I also tested creating, updating, and unchanged user permissions.</a:t>
-            </a:r>
-          </a:p>
-          <a:p>
-            <a:endParaRPr/>
-          </a:p>
-          <a:p>
-            <a:r>
-              <a:t>Bullet 2 - Easy integration:</a:t>
-            </a:r>
-          </a:p>
-          <a:p>
-            <a:r>
-              <a:t>I tested adding a new database through the registry API.</a:t>
-            </a:r>
-          </a:p>
-          <a:p>
-            <a:r>
-              <a:t>I tested that the SQLite file is validated and persisted in databases.yaml.</a:t>
-            </a:r>
-          </a:p>
-          <a:p>
-            <a:r>
-              <a:t>I also tested granting that new database to a new user.</a:t>
-            </a:r>
-          </a:p>
-          <a:p>
-            <a:endParaRPr/>
-          </a:p>
-          <a:p>
-            <a:r>
-              <a:t>Bullet 3 - Database layer:</a:t>
-            </a:r>
-          </a:p>
-          <a:p>
-            <a:r>
-              <a:t>I tested that the database registry resolves the correct SQLite file.</a:t>
-            </a:r>
-          </a:p>
-          <a:p>
-            <a:r>
-              <a:t>I tested that the schema reader can read table and column information.</a:t>
-            </a:r>
-          </a:p>
-          <a:p>
-            <a:r>
-              <a:t>I tested that the connector can run a read-only SELECT query.</a:t>
-            </a:r>
-          </a:p>
-          <a:p>
-            <a:endParaRPr/>
-          </a:p>
-          <a:p>
-            <a:r>
-              <a:t>Bullet 4 - SQL safety:</a:t>
-            </a:r>
-          </a:p>
-          <a:p>
-            <a:r>
-              <a:t>I tested that unsafe mutation SQL is blocked.</a:t>
-            </a:r>
-          </a:p>
-          <a:p>
-            <a:r>
-              <a:t>For example, dangerous commands like DELETE or DROP should not run.</a:t>
-            </a:r>
-          </a:p>
-          <a:p>
-            <a:r>
-              <a:t>I also tested that the system adds a LIMIT when needed.</a:t>
-            </a:r>
-          </a:p>
-          <a:p>
-            <a:endParaRPr/>
-          </a:p>
-          <a:p>
-            <a:r>
-              <a:t>Bullet 5 - Analysis agent:</a:t>
-            </a:r>
-          </a:p>
-          <a:p>
-            <a:r>
-              <a:t>I tested that the analysis agent returns expected rows and columns.</a:t>
-            </a:r>
-          </a:p>
-          <a:p>
-            <a:r>
-              <a:t>I tested row limits.</a:t>
-            </a:r>
-          </a:p>
-          <a:p>
-            <a:r>
-              <a:t>I tested that irrelevant questions are rejected.</a:t>
-            </a:r>
-          </a:p>
-          <a:p>
-            <a:r>
-              <a:t>I tested that offline mode only accepts exact sample questions.</a:t>
-            </a:r>
-          </a:p>
-          <a:p>
-            <a:r>
-              <a:t>I also tested that newly added databases do not get offline sample templates automatically.</a:t>
-            </a:r>
-          </a:p>
-          <a:p>
-            <a:endParaRPr/>
-          </a:p>
-          <a:p>
-            <a:r>
-              <a:t>Bullet 6 - Visualization and pipeline:</a:t>
-            </a:r>
-          </a:p>
-          <a:p>
-            <a:r>
-              <a:t>I tested that the visualization agent creates chart files and CSV files.</a:t>
-            </a:r>
-          </a:p>
-          <a:p>
-            <a:r>
-              <a:t>I tested table fallback for empty data.</a:t>
-            </a:r>
-          </a:p>
-          <a:p>
-            <a:r>
-              <a:t>I tested the full two-agent pipeline from analysis to visualization.</a:t>
-            </a:r>
-          </a:p>
-          <a:p>
-            <a:endParaRPr/>
-          </a:p>
-          <a:p>
-            <a:r>
-              <a:t>Quality checks:</a:t>
-            </a:r>
-          </a:p>
-          <a:p>
-            <a:r>
-              <a:t>Correct outputs means the system returns the expected rows, columns, and saved files.</a:t>
-            </a:r>
-          </a:p>
-          <a:p>
-            <a:r>
-              <a:t>Controlled risk means unsafe SQL and unauthorized access are blocked before execution.</a:t>
-            </a:r>
-          </a:p>
-          <a:p>
-            <a:r>
-              <a:t>Integration path means a new database and a new user can work through the orchestrator end to end.</a:t>
-            </a:r>
-          </a:p>
-          <a:p>
-            <a:endParaRPr/>
-          </a:p>
-          <a:p>
-            <a:r>
-              <a:t>Production next steps:</a:t>
-            </a:r>
-          </a:p>
-          <a:p>
-            <a:r>
-              <a:t>First, I would add a golden SQL and result benchmark for more natural language questions.</a:t>
-            </a:r>
-          </a:p>
-          <a:p>
-            <a:r>
-              <a:t>Second, I would replace the YAML demo users with real authentication, roles, and audit logs.</a:t>
-            </a:r>
-          </a:p>
-          <a:p>
-            <a:r>
-              <a:t>Third, I would monitor latency, API cost, and runtime errors.</a:t>
-            </a:r>
-          </a:p>
-          <a:p>
-            <a:r>
-              <a:t>Fourth, I would deploy the system with managed database access and environment-specific secrets.</a:t>
-            </a:r>
-          </a:p>
-          <a:p>
-            <a:endParaRPr/>
-          </a:p>
-          <a:p>
-            <a:r>
-              <a:t>Closing:</a:t>
-            </a:r>
-          </a:p>
-          <a:p>
-            <a:r>
-              <a:t>My final point is that this is a controlled and testable MVP.</a:t>
-            </a:r>
-          </a:p>
-          <a:p>
-            <a:r>
-              <a:t>It satisfies the case requirements and has a clear path to production improvements.</a:t>
-            </a:r>
-          </a:p>
-          <a:p>
-            <a:endParaRPr/>
-          </a:p>
-          <a:p>
-            <a:r>
-              <a:t>[Sources]</a:t>
-            </a:r>
-          </a:p>
-          <a:p>
-            <a:r>
-              <a:t>- Local project source code and README in C:/Users/win11/PycharmProjects/autonomous-ai-data-agents.</a:t>
-            </a:r>
+            <a:endParaRPr dirty="0"/>
           </a:p>
         </p:txBody>
       </p:sp>
@@ -2038,6 +1013,7 @@
           <a:lstStyle/>
           <a:p>
             <a:pPr algn="l">
+              <a:buNone/>
               <a:defRPr sz="975" b="1">
                 <a:solidFill>
                   <a:srgbClr val="8EC5F4"/>
@@ -2088,6 +1064,7 @@
           <a:lstStyle/>
           <a:p>
             <a:pPr algn="l">
+              <a:buNone/>
               <a:defRPr sz="3900" b="1">
                 <a:solidFill>
                   <a:srgbClr val="FFFFFF"/>
@@ -2105,6 +1082,7 @@
           </a:p>
           <a:p>
             <a:pPr algn="l">
+              <a:buNone/>
               <a:defRPr sz="3900" b="1">
                 <a:solidFill>
                   <a:srgbClr val="FFFFFF"/>
@@ -2155,6 +1133,7 @@
           <a:lstStyle/>
           <a:p>
             <a:pPr algn="l">
+              <a:buNone/>
               <a:defRPr sz="1650" b="0">
                 <a:solidFill>
                   <a:srgbClr val="D7E6F5"/>
@@ -2205,6 +1184,7 @@
           <a:lstStyle/>
           <a:p>
             <a:pPr algn="l">
+              <a:buNone/>
               <a:defRPr sz="1350" b="0">
                 <a:solidFill>
                   <a:srgbClr val="B8CDE1"/>
@@ -2255,6 +1235,7 @@
           <a:lstStyle/>
           <a:p>
             <a:pPr algn="l">
+              <a:buNone/>
               <a:defRPr sz="975" b="1">
                 <a:solidFill>
                   <a:srgbClr val="1F77B4"/>
@@ -2262,7 +1243,7 @@
               </a:defRPr>
             </a:pPr>
             <a:r>
-              <a:rPr sz="975" b="1">
+              <a:rPr sz="1400" b="1">
                 <a:solidFill>
                   <a:srgbClr val="1F77B4"/>
                 </a:solidFill>
@@ -2305,6 +1286,7 @@
           <a:lstStyle/>
           <a:p>
             <a:pPr algn="l">
+              <a:buNone/>
               <a:defRPr sz="2100" b="0">
                 <a:solidFill>
                   <a:srgbClr val="132238"/>
@@ -2386,6 +1368,7 @@
           <a:lstStyle/>
           <a:p>
             <a:pPr algn="l">
+              <a:buNone/>
               <a:defRPr sz="2100" b="0">
                 <a:solidFill>
                   <a:srgbClr val="132238"/>
@@ -2467,6 +1450,7 @@
           <a:lstStyle/>
           <a:p>
             <a:pPr algn="l">
+              <a:buNone/>
               <a:defRPr sz="2100" b="0">
                 <a:solidFill>
                   <a:srgbClr val="132238"/>
@@ -2548,6 +1532,7 @@
           <a:lstStyle/>
           <a:p>
             <a:pPr algn="l">
+              <a:buNone/>
               <a:defRPr sz="2100" b="0">
                 <a:solidFill>
                   <a:srgbClr val="132238"/>
@@ -2667,6 +1652,7 @@
           <a:lstStyle/>
           <a:p>
             <a:pPr algn="l">
+              <a:buNone/>
               <a:defRPr sz="975" b="1">
                 <a:solidFill>
                   <a:srgbClr val="1F77B4"/>
@@ -2717,6 +1703,7 @@
           <a:lstStyle/>
           <a:p>
             <a:pPr algn="l">
+              <a:buNone/>
               <a:defRPr sz="2850" b="1">
                 <a:solidFill>
                   <a:srgbClr val="132238"/>
@@ -2798,6 +1785,7 @@
           <a:lstStyle/>
           <a:p>
             <a:pPr algn="l">
+              <a:buNone/>
               <a:defRPr sz="900" b="0">
                 <a:solidFill>
                   <a:srgbClr val="7A8695"/>
@@ -2810,7 +1798,7 @@
                   <a:srgbClr val="7A8695"/>
                 </a:solidFill>
               </a:rPr>
-              <a:t>Autonomous AI Agents Case  |  2/5</a:t>
+              <a:t>Autonomous AI Agents Case  |  2/4</a:t>
             </a:r>
           </a:p>
         </p:txBody>
@@ -2881,6 +1869,7 @@
           <a:lstStyle/>
           <a:p>
             <a:pPr algn="l">
+              <a:buNone/>
               <a:defRPr sz="975" b="1">
                 <a:solidFill>
                   <a:srgbClr val="5E6B7A"/>
@@ -2964,6 +1953,7 @@
           <a:lstStyle/>
           <a:p>
             <a:pPr algn="l">
+              <a:buNone/>
               <a:defRPr sz="975" b="1">
                 <a:solidFill>
                   <a:srgbClr val="5E6B7A"/>
@@ -3047,6 +2037,7 @@
           <a:lstStyle/>
           <a:p>
             <a:pPr algn="l">
+              <a:buNone/>
               <a:defRPr sz="975" b="1">
                 <a:solidFill>
                   <a:srgbClr val="5E6B7A"/>
@@ -3130,6 +2121,7 @@
           <a:lstStyle/>
           <a:p>
             <a:pPr algn="l">
+              <a:buNone/>
               <a:defRPr sz="975" b="1">
                 <a:solidFill>
                   <a:srgbClr val="5E6B7A"/>
@@ -3215,6 +2207,7 @@
           <a:lstStyle/>
           <a:p>
             <a:pPr algn="ctr">
+              <a:buNone/>
               <a:defRPr sz="1350" b="1">
                 <a:solidFill>
                   <a:srgbClr val="132238"/>
@@ -3265,6 +2258,7 @@
           <a:lstStyle/>
           <a:p>
             <a:pPr algn="ctr">
+              <a:buNone/>
               <a:defRPr sz="975" b="0">
                 <a:solidFill>
                   <a:srgbClr val="5E6B7A"/>
@@ -3350,6 +2344,7 @@
           <a:lstStyle/>
           <a:p>
             <a:pPr algn="ctr">
+              <a:buNone/>
               <a:defRPr sz="1350" b="1">
                 <a:solidFill>
                   <a:srgbClr val="132238"/>
@@ -3400,6 +2395,7 @@
           <a:lstStyle/>
           <a:p>
             <a:pPr algn="ctr">
+              <a:buNone/>
               <a:defRPr sz="975" b="0">
                 <a:solidFill>
                   <a:srgbClr val="5E6B7A"/>
@@ -3485,6 +2481,7 @@
           <a:lstStyle/>
           <a:p>
             <a:pPr algn="ctr">
+              <a:buNone/>
               <a:defRPr sz="1500" b="1">
                 <a:solidFill>
                   <a:srgbClr val="132238"/>
@@ -3535,6 +2532,7 @@
           <a:lstStyle/>
           <a:p>
             <a:pPr algn="ctr">
+              <a:buNone/>
               <a:defRPr sz="975" b="0">
                 <a:solidFill>
                   <a:srgbClr val="5E6B7A"/>
@@ -3620,6 +2618,7 @@
           <a:lstStyle/>
           <a:p>
             <a:pPr algn="ctr">
+              <a:buNone/>
               <a:defRPr sz="1350" b="1">
                 <a:solidFill>
                   <a:srgbClr val="132238"/>
@@ -3670,6 +2669,7 @@
           <a:lstStyle/>
           <a:p>
             <a:pPr algn="ctr">
+              <a:buNone/>
               <a:defRPr sz="975" b="0">
                 <a:solidFill>
                   <a:srgbClr val="5E6B7A"/>
@@ -3755,6 +2755,7 @@
           <a:lstStyle/>
           <a:p>
             <a:pPr algn="ctr">
+              <a:buNone/>
               <a:defRPr sz="1350" b="1">
                 <a:solidFill>
                   <a:srgbClr val="132238"/>
@@ -3805,6 +2806,7 @@
           <a:lstStyle/>
           <a:p>
             <a:pPr algn="ctr">
+              <a:buNone/>
               <a:defRPr sz="975" b="0">
                 <a:solidFill>
                   <a:srgbClr val="5E6B7A"/>
@@ -3923,6 +2925,7 @@
           <a:lstStyle/>
           <a:p>
             <a:pPr algn="l">
+              <a:buNone/>
               <a:defRPr sz="975" b="1">
                 <a:solidFill>
                   <a:srgbClr val="5E6B7A"/>
@@ -3973,6 +2976,7 @@
           <a:lstStyle/>
           <a:p>
             <a:pPr algn="ctr">
+              <a:buNone/>
               <a:defRPr sz="1125" b="1">
                 <a:solidFill>
                   <a:srgbClr val="5E6B7A"/>
@@ -4058,6 +3062,7 @@
           <a:lstStyle/>
           <a:p>
             <a:pPr algn="ctr">
+              <a:buNone/>
               <a:defRPr sz="1425" b="1">
                 <a:solidFill>
                   <a:srgbClr val="132238"/>
@@ -4108,6 +3113,7 @@
           <a:lstStyle/>
           <a:p>
             <a:pPr algn="ctr">
+              <a:buNone/>
               <a:defRPr sz="975" b="0">
                 <a:solidFill>
                   <a:srgbClr val="5E6B7A"/>
@@ -4193,6 +3199,7 @@
           <a:lstStyle/>
           <a:p>
             <a:pPr algn="ctr">
+              <a:buNone/>
               <a:defRPr sz="1425" b="1">
                 <a:solidFill>
                   <a:srgbClr val="132238"/>
@@ -4243,6 +3250,7 @@
           <a:lstStyle/>
           <a:p>
             <a:pPr algn="ctr">
+              <a:buNone/>
               <a:defRPr sz="975" b="0">
                 <a:solidFill>
                   <a:srgbClr val="5E6B7A"/>
@@ -4328,6 +3336,7 @@
           <a:lstStyle/>
           <a:p>
             <a:pPr algn="ctr">
+              <a:buNone/>
               <a:defRPr sz="1125" b="1">
                 <a:solidFill>
                   <a:srgbClr val="132238"/>
@@ -4378,6 +3387,7 @@
           <a:lstStyle/>
           <a:p>
             <a:pPr algn="ctr">
+              <a:buNone/>
               <a:defRPr sz="825" b="0">
                 <a:solidFill>
                   <a:srgbClr val="5E6B7A"/>
@@ -4413,6 +3423,132 @@
           <a:xfrm>
             <a:off x="2819400" y="5600700"/>
             <a:ext cx="1809750" cy="647700"/>
+          </a:xfrm>
+          <a:prstGeom prst="roundRect">
+            <a:avLst>
+              <a:gd name="adj" fmla="val 20588"/>
+            </a:avLst>
+          </a:prstGeom>
+          <a:noFill/>
+          <a:ln w="0">
+            <a:noFill/>
+            <a:prstDash val="solid"/>
+          </a:ln>
+        </p:spPr>
+        <p:txBody>
+          <a:bodyPr/>
+          <a:lstStyle/>
+          <a:p>
+            <a:endParaRPr/>
+          </a:p>
+        </p:txBody>
+      </p:sp>
+      <p:sp>
+        <p:nvSpPr>
+          <p:cNvPr id="42" name="database-onboarding-title">
+            <a:extLst>
+              <a:ext uri="{FF2B5EF4-FFF2-40B4-BE49-F238E27FC236}">
+                <a16:creationId xmlns:a16="http://schemas.microsoft.com/office/drawing/2014/main" id="{BBE9A85B-E63E-49D9-A145-302569820FC2}"/>
+              </a:ext>
+            </a:extLst>
+          </p:cNvPr>
+          <p:cNvSpPr>
+            <a:spLocks noGrp="1"/>
+          </p:cNvSpPr>
+          <p:nvPr/>
+        </p:nvSpPr>
+        <p:spPr>
+          <a:xfrm>
+            <a:off x="2933700" y="5715000"/>
+            <a:ext cx="1581150" cy="228600"/>
+          </a:xfrm>
+          <a:prstGeom prst="rect">
+            <a:avLst/>
+          </a:prstGeom>
+          <a:noFill/>
+          <a:ln w="0">
+            <a:noFill/>
+            <a:prstDash val="solid"/>
+          </a:ln>
+        </p:spPr>
+        <p:txBody>
+          <a:bodyPr/>
+          <a:lstStyle/>
+          <a:p>
+            <a:pPr algn="ctr">
+              <a:buNone/>
+              <a:defRPr sz="1125" b="1">
+                <a:solidFill>
+                  <a:srgbClr val="132238"/>
+                </a:solidFill>
+              </a:defRPr>
+            </a:pPr>
+            <a:endParaRPr/>
+          </a:p>
+        </p:txBody>
+      </p:sp>
+      <p:sp>
+        <p:nvSpPr>
+          <p:cNvPr id="43" name="database-onboarding-body">
+            <a:extLst>
+              <a:ext uri="{FF2B5EF4-FFF2-40B4-BE49-F238E27FC236}">
+                <a16:creationId xmlns:a16="http://schemas.microsoft.com/office/drawing/2014/main" id="{C01CFA38-3AF5-496E-9AE8-1998488C95C2}"/>
+              </a:ext>
+            </a:extLst>
+          </p:cNvPr>
+          <p:cNvSpPr>
+            <a:spLocks noGrp="1"/>
+          </p:cNvSpPr>
+          <p:nvPr/>
+        </p:nvSpPr>
+        <p:spPr>
+          <a:xfrm>
+            <a:off x="2952750" y="5981700"/>
+            <a:ext cx="1543050" cy="209550"/>
+          </a:xfrm>
+          <a:prstGeom prst="rect">
+            <a:avLst/>
+          </a:prstGeom>
+          <a:noFill/>
+          <a:ln w="0">
+            <a:noFill/>
+            <a:prstDash val="solid"/>
+          </a:ln>
+        </p:spPr>
+        <p:txBody>
+          <a:bodyPr/>
+          <a:lstStyle/>
+          <a:p>
+            <a:pPr algn="ctr">
+              <a:buNone/>
+              <a:defRPr sz="825" b="0">
+                <a:solidFill>
+                  <a:srgbClr val="5E6B7A"/>
+                </a:solidFill>
+              </a:defRPr>
+            </a:pPr>
+            <a:endParaRPr/>
+          </a:p>
+        </p:txBody>
+      </p:sp>
+      <p:sp>
+        <p:nvSpPr>
+          <p:cNvPr id="44" name="data-safety">
+            <a:extLst>
+              <a:ext uri="{FF2B5EF4-FFF2-40B4-BE49-F238E27FC236}">
+                <a16:creationId xmlns:a16="http://schemas.microsoft.com/office/drawing/2014/main" id="{76716C2D-4069-4671-A689-1AD967560C7E}"/>
+              </a:ext>
+            </a:extLst>
+          </p:cNvPr>
+          <p:cNvSpPr>
+            <a:spLocks noGrp="1"/>
+          </p:cNvSpPr>
+          <p:nvPr/>
+        </p:nvSpPr>
+        <p:spPr>
+          <a:xfrm>
+            <a:off x="4895850" y="5600700"/>
+            <a:ext cx="1981200" cy="647700"/>
           </a:xfrm>
           <a:prstGeom prst="roundRect">
             <a:avLst>
@@ -4432,22 +3568,22 @@
       </p:sp>
       <p:sp>
         <p:nvSpPr>
-          <p:cNvPr id="42" name="database-onboarding-title">
-            <a:extLst>
-              <a:ext uri="{FF2B5EF4-FFF2-40B4-BE49-F238E27FC236}">
-                <a16:creationId xmlns:a16="http://schemas.microsoft.com/office/drawing/2014/main" id="{BBE9A85B-E63E-49D9-A145-302569820FC2}"/>
-              </a:ext>
-            </a:extLst>
-          </p:cNvPr>
-          <p:cNvSpPr>
-            <a:spLocks noGrp="1"/>
-          </p:cNvSpPr>
-          <p:nvPr/>
-        </p:nvSpPr>
-        <p:spPr>
-          <a:xfrm>
-            <a:off x="2933700" y="5715000"/>
-            <a:ext cx="1581150" cy="228600"/>
+          <p:cNvPr id="45" name="data-safety-title">
+            <a:extLst>
+              <a:ext uri="{FF2B5EF4-FFF2-40B4-BE49-F238E27FC236}">
+                <a16:creationId xmlns:a16="http://schemas.microsoft.com/office/drawing/2014/main" id="{12DC5CFF-201A-4C86-B301-3B1D3ED3270A}"/>
+              </a:ext>
+            </a:extLst>
+          </p:cNvPr>
+          <p:cNvSpPr>
+            <a:spLocks noGrp="1"/>
+          </p:cNvSpPr>
+          <p:nvPr/>
+        </p:nvSpPr>
+        <p:spPr>
+          <a:xfrm>
+            <a:off x="5010150" y="5715000"/>
+            <a:ext cx="1752600" cy="228600"/>
           </a:xfrm>
           <a:prstGeom prst="rect">
             <a:avLst/>
@@ -4463,6 +3599,7 @@
           <a:lstStyle/>
           <a:p>
             <a:pPr algn="ctr">
+              <a:buNone/>
               <a:defRPr sz="1125" b="1">
                 <a:solidFill>
                   <a:srgbClr val="132238"/>
@@ -4475,29 +3612,29 @@
                   <a:srgbClr val="132238"/>
                 </a:solidFill>
               </a:rPr>
-              <a:t>DB onboarding</a:t>
-            </a:r>
-          </a:p>
-        </p:txBody>
-      </p:sp>
-      <p:sp>
-        <p:nvSpPr>
-          <p:cNvPr id="43" name="database-onboarding-body">
-            <a:extLst>
-              <a:ext uri="{FF2B5EF4-FFF2-40B4-BE49-F238E27FC236}">
-                <a16:creationId xmlns:a16="http://schemas.microsoft.com/office/drawing/2014/main" id="{C01CFA38-3AF5-496E-9AE8-1998488C95C2}"/>
-              </a:ext>
-            </a:extLst>
-          </p:cNvPr>
-          <p:cNvSpPr>
-            <a:spLocks noGrp="1"/>
-          </p:cNvSpPr>
-          <p:nvPr/>
-        </p:nvSpPr>
-        <p:spPr>
-          <a:xfrm>
-            <a:off x="2952750" y="5981700"/>
-            <a:ext cx="1543050" cy="209550"/>
+              <a:t>Safe data path</a:t>
+            </a:r>
+          </a:p>
+        </p:txBody>
+      </p:sp>
+      <p:sp>
+        <p:nvSpPr>
+          <p:cNvPr id="46" name="data-safety-body">
+            <a:extLst>
+              <a:ext uri="{FF2B5EF4-FFF2-40B4-BE49-F238E27FC236}">
+                <a16:creationId xmlns:a16="http://schemas.microsoft.com/office/drawing/2014/main" id="{FE2F6BCC-7769-4FBD-8B3F-266EF21E1149}"/>
+              </a:ext>
+            </a:extLst>
+          </p:cNvPr>
+          <p:cNvSpPr>
+            <a:spLocks noGrp="1"/>
+          </p:cNvSpPr>
+          <p:nvPr/>
+        </p:nvSpPr>
+        <p:spPr>
+          <a:xfrm>
+            <a:off x="5029200" y="5981700"/>
+            <a:ext cx="1714500" cy="209550"/>
           </a:xfrm>
           <a:prstGeom prst="rect">
             <a:avLst/>
@@ -4513,6 +3650,7 @@
           <a:lstStyle/>
           <a:p>
             <a:pPr algn="ctr">
+              <a:buNone/>
               <a:defRPr sz="825" b="0">
                 <a:solidFill>
                   <a:srgbClr val="5E6B7A"/>
@@ -4525,29 +3663,29 @@
                   <a:srgbClr val="5E6B7A"/>
                 </a:solidFill>
               </a:rPr>
-              <a:t>Streamlit + CLI + YAML</a:t>
-            </a:r>
-          </a:p>
-        </p:txBody>
-      </p:sp>
-      <p:sp>
-        <p:nvSpPr>
-          <p:cNvPr id="44" name="data-safety">
-            <a:extLst>
-              <a:ext uri="{FF2B5EF4-FFF2-40B4-BE49-F238E27FC236}">
-                <a16:creationId xmlns:a16="http://schemas.microsoft.com/office/drawing/2014/main" id="{76716C2D-4069-4671-A689-1AD967560C7E}"/>
-              </a:ext>
-            </a:extLst>
-          </p:cNvPr>
-          <p:cNvSpPr>
-            <a:spLocks noGrp="1"/>
-          </p:cNvSpPr>
-          <p:nvPr/>
-        </p:nvSpPr>
-        <p:spPr>
-          <a:xfrm>
-            <a:off x="4895850" y="5600700"/>
-            <a:ext cx="1981200" cy="647700"/>
+              <a:t>SQLGuard + read-only SQLite</a:t>
+            </a:r>
+          </a:p>
+        </p:txBody>
+      </p:sp>
+      <p:sp>
+        <p:nvSpPr>
+          <p:cNvPr id="47" name="chart-factory">
+            <a:extLst>
+              <a:ext uri="{FF2B5EF4-FFF2-40B4-BE49-F238E27FC236}">
+                <a16:creationId xmlns:a16="http://schemas.microsoft.com/office/drawing/2014/main" id="{75A9A410-616A-464A-AEF8-E11ABF152621}"/>
+              </a:ext>
+            </a:extLst>
+          </p:cNvPr>
+          <p:cNvSpPr>
+            <a:spLocks noGrp="1"/>
+          </p:cNvSpPr>
+          <p:nvPr/>
+        </p:nvSpPr>
+        <p:spPr>
+          <a:xfrm>
+            <a:off x="7143750" y="5600700"/>
+            <a:ext cx="1809750" cy="647700"/>
           </a:xfrm>
           <a:prstGeom prst="roundRect">
             <a:avLst>
@@ -4567,141 +3705,6 @@
       </p:sp>
       <p:sp>
         <p:nvSpPr>
-          <p:cNvPr id="45" name="data-safety-title">
-            <a:extLst>
-              <a:ext uri="{FF2B5EF4-FFF2-40B4-BE49-F238E27FC236}">
-                <a16:creationId xmlns:a16="http://schemas.microsoft.com/office/drawing/2014/main" id="{12DC5CFF-201A-4C86-B301-3B1D3ED3270A}"/>
-              </a:ext>
-            </a:extLst>
-          </p:cNvPr>
-          <p:cNvSpPr>
-            <a:spLocks noGrp="1"/>
-          </p:cNvSpPr>
-          <p:nvPr/>
-        </p:nvSpPr>
-        <p:spPr>
-          <a:xfrm>
-            <a:off x="5010150" y="5715000"/>
-            <a:ext cx="1752600" cy="228600"/>
-          </a:xfrm>
-          <a:prstGeom prst="rect">
-            <a:avLst/>
-          </a:prstGeom>
-          <a:noFill/>
-          <a:ln w="0">
-            <a:noFill/>
-            <a:prstDash val="solid"/>
-          </a:ln>
-        </p:spPr>
-        <p:txBody>
-          <a:bodyPr/>
-          <a:lstStyle/>
-          <a:p>
-            <a:pPr algn="ctr">
-              <a:defRPr sz="1125" b="1">
-                <a:solidFill>
-                  <a:srgbClr val="132238"/>
-                </a:solidFill>
-              </a:defRPr>
-            </a:pPr>
-            <a:r>
-              <a:rPr sz="1125" b="1">
-                <a:solidFill>
-                  <a:srgbClr val="132238"/>
-                </a:solidFill>
-              </a:rPr>
-              <a:t>Safe data path</a:t>
-            </a:r>
-          </a:p>
-        </p:txBody>
-      </p:sp>
-      <p:sp>
-        <p:nvSpPr>
-          <p:cNvPr id="46" name="data-safety-body">
-            <a:extLst>
-              <a:ext uri="{FF2B5EF4-FFF2-40B4-BE49-F238E27FC236}">
-                <a16:creationId xmlns:a16="http://schemas.microsoft.com/office/drawing/2014/main" id="{FE2F6BCC-7769-4FBD-8B3F-266EF21E1149}"/>
-              </a:ext>
-            </a:extLst>
-          </p:cNvPr>
-          <p:cNvSpPr>
-            <a:spLocks noGrp="1"/>
-          </p:cNvSpPr>
-          <p:nvPr/>
-        </p:nvSpPr>
-        <p:spPr>
-          <a:xfrm>
-            <a:off x="5029200" y="5981700"/>
-            <a:ext cx="1714500" cy="209550"/>
-          </a:xfrm>
-          <a:prstGeom prst="rect">
-            <a:avLst/>
-          </a:prstGeom>
-          <a:noFill/>
-          <a:ln w="0">
-            <a:noFill/>
-            <a:prstDash val="solid"/>
-          </a:ln>
-        </p:spPr>
-        <p:txBody>
-          <a:bodyPr/>
-          <a:lstStyle/>
-          <a:p>
-            <a:pPr algn="ctr">
-              <a:defRPr sz="825" b="0">
-                <a:solidFill>
-                  <a:srgbClr val="5E6B7A"/>
-                </a:solidFill>
-              </a:defRPr>
-            </a:pPr>
-            <a:r>
-              <a:rPr sz="825" b="0">
-                <a:solidFill>
-                  <a:srgbClr val="5E6B7A"/>
-                </a:solidFill>
-              </a:rPr>
-              <a:t>SQLGuard + read-only SQLite</a:t>
-            </a:r>
-          </a:p>
-        </p:txBody>
-      </p:sp>
-      <p:sp>
-        <p:nvSpPr>
-          <p:cNvPr id="47" name="chart-factory">
-            <a:extLst>
-              <a:ext uri="{FF2B5EF4-FFF2-40B4-BE49-F238E27FC236}">
-                <a16:creationId xmlns:a16="http://schemas.microsoft.com/office/drawing/2014/main" id="{75A9A410-616A-464A-AEF8-E11ABF152621}"/>
-              </a:ext>
-            </a:extLst>
-          </p:cNvPr>
-          <p:cNvSpPr>
-            <a:spLocks noGrp="1"/>
-          </p:cNvSpPr>
-          <p:nvPr/>
-        </p:nvSpPr>
-        <p:spPr>
-          <a:xfrm>
-            <a:off x="7143750" y="5600700"/>
-            <a:ext cx="1809750" cy="647700"/>
-          </a:xfrm>
-          <a:prstGeom prst="roundRect">
-            <a:avLst>
-              <a:gd name="adj" fmla="val 20588"/>
-            </a:avLst>
-          </a:prstGeom>
-          <a:solidFill>
-            <a:srgbClr val="FFFFFF"/>
-          </a:solidFill>
-          <a:ln w="9525">
-            <a:solidFill>
-              <a:srgbClr val="D9E2EC"/>
-            </a:solidFill>
-            <a:prstDash val="solid"/>
-          </a:ln>
-        </p:spPr>
-      </p:sp>
-      <p:sp>
-        <p:nvSpPr>
           <p:cNvPr id="48" name="chart-factory-title">
             <a:extLst>
               <a:ext uri="{FF2B5EF4-FFF2-40B4-BE49-F238E27FC236}">
@@ -4733,6 +3736,7 @@
           <a:lstStyle/>
           <a:p>
             <a:pPr algn="ctr">
+              <a:buNone/>
               <a:defRPr sz="1125" b="1">
                 <a:solidFill>
                   <a:srgbClr val="132238"/>
@@ -4783,6 +3787,7 @@
           <a:lstStyle/>
           <a:p>
             <a:pPr algn="ctr">
+              <a:buNone/>
               <a:defRPr sz="825" b="0">
                 <a:solidFill>
                   <a:srgbClr val="5E6B7A"/>
@@ -4868,6 +3873,7 @@
           <a:lstStyle/>
           <a:p>
             <a:pPr algn="ctr">
+              <a:buNone/>
               <a:defRPr sz="1275" b="1">
                 <a:solidFill>
                   <a:srgbClr val="132238"/>
@@ -4918,6 +3924,7 @@
           <a:lstStyle/>
           <a:p>
             <a:pPr algn="ctr">
+              <a:buNone/>
               <a:defRPr sz="900" b="0">
                 <a:solidFill>
                   <a:srgbClr val="5E6B7A"/>
@@ -4935,6 +3942,7 @@
           </a:p>
           <a:p>
             <a:pPr algn="ctr">
+              <a:buNone/>
               <a:defRPr sz="900" b="0">
                 <a:solidFill>
                   <a:srgbClr val="5E6B7A"/>
@@ -4954,7 +3962,7 @@
       </p:sp>
       <p:cxnSp>
         <p:nvCxnSpPr>
-          <p:cNvPr id="117" name="直接箭头连接符 116"/>
+          <p:cNvPr id="706" name="直接箭头连接符 116"/>
           <p:cNvCxnSpPr>
             <a:stCxn id="13" idx="3"/>
             <a:endCxn id="19" idx="1"/>
@@ -4980,7 +3988,7 @@
       </p:cxnSp>
       <p:cxnSp>
         <p:nvCxnSpPr>
-          <p:cNvPr id="118" name="直接箭头连接符 117"/>
+          <p:cNvPr id="707" name="直接箭头连接符 117"/>
           <p:cNvCxnSpPr>
             <a:stCxn id="16" idx="3"/>
             <a:endCxn id="19" idx="1"/>
@@ -5006,7 +4014,7 @@
       </p:cxnSp>
       <p:cxnSp>
         <p:nvCxnSpPr>
-          <p:cNvPr id="119" name="直接箭头连接符 118"/>
+          <p:cNvPr id="708" name="直接箭头连接符 118"/>
           <p:cNvCxnSpPr>
             <a:stCxn id="19" idx="3"/>
             <a:endCxn id="22" idx="1"/>
@@ -5032,7 +4040,7 @@
       </p:cxnSp>
       <p:cxnSp>
         <p:nvCxnSpPr>
-          <p:cNvPr id="120" name="直接箭头连接符 119"/>
+          <p:cNvPr id="709" name="直接箭头连接符 119"/>
           <p:cNvCxnSpPr>
             <a:stCxn id="19" idx="3"/>
             <a:endCxn id="25" idx="1"/>
@@ -5058,7 +4066,7 @@
       </p:cxnSp>
       <p:cxnSp>
         <p:nvCxnSpPr>
-          <p:cNvPr id="121" name="直接箭头连接符 120"/>
+          <p:cNvPr id="710" name="直接箭头连接符 120"/>
           <p:cNvCxnSpPr>
             <a:stCxn id="19" idx="2"/>
             <a:endCxn id="32" idx="0"/>
@@ -5084,7 +4092,7 @@
       </p:cxnSp>
       <p:cxnSp>
         <p:nvCxnSpPr>
-          <p:cNvPr id="122" name="直接箭头连接符 121"/>
+          <p:cNvPr id="711" name="直接箭头连接符 121"/>
           <p:cNvCxnSpPr>
             <a:stCxn id="32" idx="3"/>
             <a:endCxn id="35" idx="1"/>
@@ -5110,7 +4118,7 @@
       </p:cxnSp>
       <p:cxnSp>
         <p:nvCxnSpPr>
-          <p:cNvPr id="123" name="直接箭头连接符 122"/>
+          <p:cNvPr id="712" name="直接箭头连接符 122"/>
           <p:cNvCxnSpPr>
             <a:stCxn id="35" idx="3"/>
             <a:endCxn id="50" idx="1"/>
@@ -5136,7 +4144,7 @@
       </p:cxnSp>
       <p:cxnSp>
         <p:nvCxnSpPr>
-          <p:cNvPr id="124" name="直接箭头连接符 123"/>
+          <p:cNvPr id="713" name="直接箭头连接符 123"/>
           <p:cNvCxnSpPr>
             <a:stCxn id="38" idx="0"/>
             <a:endCxn id="32" idx="1"/>
@@ -5162,7 +4170,7 @@
       </p:cxnSp>
       <p:cxnSp>
         <p:nvCxnSpPr>
-          <p:cNvPr id="125" name="直接箭头连接符 124"/>
+          <p:cNvPr id="714" name="直接箭头连接符 124"/>
           <p:cNvCxnSpPr>
             <a:stCxn id="32" idx="2"/>
             <a:endCxn id="44" idx="0"/>
@@ -5188,7 +4196,7 @@
       </p:cxnSp>
       <p:cxnSp>
         <p:nvCxnSpPr>
-          <p:cNvPr id="126" name="直接箭头连接符 125"/>
+          <p:cNvPr id="715" name="直接箭头连接符 125"/>
           <p:cNvCxnSpPr>
             <a:stCxn id="35" idx="2"/>
             <a:endCxn id="47" idx="0"/>
@@ -5280,6 +4288,7 @@
           <a:lstStyle/>
           <a:p>
             <a:pPr algn="ctr">
+              <a:buNone/>
               <a:defRPr sz="825" b="1">
                 <a:solidFill>
                   <a:srgbClr val="FF7F0E"/>
@@ -5297,6 +4306,7 @@
           </a:p>
           <a:p>
             <a:pPr algn="ctr">
+              <a:buNone/>
               <a:defRPr sz="825" b="1">
                 <a:solidFill>
                   <a:srgbClr val="FF7F0E"/>
@@ -5311,6 +4321,275 @@
               </a:rPr>
               <a:t>Result</a:t>
             </a:r>
+          </a:p>
+        </p:txBody>
+      </p:sp>
+      <p:cxnSp>
+        <p:nvCxnSpPr>
+          <p:cNvPr id="718" name="db-onboarding-to-registry"/>
+          <p:cNvCxnSpPr>
+            <a:stCxn id="41" idx="0"/>
+            <a:endCxn id="25" idx="2"/>
+          </p:cNvCxnSpPr>
+          <p:nvPr/>
+        </p:nvCxnSpPr>
+        <p:spPr>
+          <a:xfrm flipV="1">
+            <a:off x="3724275" y="3486150"/>
+            <a:ext cx="3467100" cy="2114550"/>
+          </a:xfrm>
+          <a:prstGeom prst="bentConnector4">
+            <a:avLst>
+              <a:gd name="adj1" fmla="val 0"/>
+              <a:gd name="adj2" fmla="val 50000"/>
+            </a:avLst>
+          </a:prstGeom>
+          <a:ln w="0" cap="rnd">
+            <a:noFill/>
+            <a:prstDash val="solid"/>
+            <a:round/>
+            <a:headEnd type="arrow" w="sm" len="sm"/>
+          </a:ln>
+        </p:spPr>
+      </p:cxnSp>
+      <p:cxnSp>
+        <p:nvCxnSpPr>
+          <p:cNvPr id="719" name="db-onboarding-to-registry-routed"/>
+          <p:cNvCxnSpPr>
+            <a:stCxn id="41" idx="1"/>
+            <a:endCxn id="25" idx="2"/>
+          </p:cNvCxnSpPr>
+          <p:nvPr/>
+        </p:nvCxnSpPr>
+        <p:spPr>
+          <a:xfrm flipV="1">
+            <a:off x="2819400" y="3486150"/>
+            <a:ext cx="4371975" cy="2438400"/>
+          </a:xfrm>
+          <a:prstGeom prst="bentConnector2">
+            <a:avLst/>
+          </a:prstGeom>
+          <a:ln w="0" cap="rnd">
+            <a:noFill/>
+            <a:prstDash val="solid"/>
+            <a:round/>
+            <a:headEnd type="arrow" w="sm" len="sm"/>
+          </a:ln>
+        </p:spPr>
+      </p:cxnSp>
+      <p:sp>
+        <p:nvSpPr>
+          <p:cNvPr id="384" name="db-onboarding-config-line-left">
+            <a:extLst>
+              <a:ext uri="{FF2B5EF4-FFF2-40B4-BE49-F238E27FC236}">
+                <a16:creationId xmlns:a16="http://schemas.microsoft.com/office/drawing/2014/main" id="{7AEDAE1F-2240-4C49-8D16-CC4AAD0AA3DC}"/>
+              </a:ext>
+            </a:extLst>
+          </p:cNvPr>
+          <p:cNvSpPr>
+            <a:spLocks noGrp="1"/>
+          </p:cNvSpPr>
+          <p:nvPr/>
+        </p:nvSpPr>
+        <p:spPr>
+          <a:xfrm>
+            <a:off x="2724150" y="5924550"/>
+            <a:ext cx="95250" cy="0"/>
+          </a:xfrm>
+          <a:prstGeom prst="line">
+            <a:avLst/>
+          </a:prstGeom>
+          <a:noFill/>
+          <a:ln w="0">
+            <a:noFill/>
+            <a:prstDash val="solid"/>
+          </a:ln>
+        </p:spPr>
+        <p:txBody>
+          <a:bodyPr/>
+          <a:lstStyle/>
+          <a:p>
+            <a:endParaRPr/>
+          </a:p>
+        </p:txBody>
+      </p:sp>
+      <p:sp>
+        <p:nvSpPr>
+          <p:cNvPr id="385" name="db-onboarding-config-line-up">
+            <a:extLst>
+              <a:ext uri="{FF2B5EF4-FFF2-40B4-BE49-F238E27FC236}">
+                <a16:creationId xmlns:a16="http://schemas.microsoft.com/office/drawing/2014/main" id="{2D1E8A4B-77A9-47D0-9A4A-40DD49BA3E2E}"/>
+              </a:ext>
+            </a:extLst>
+          </p:cNvPr>
+          <p:cNvSpPr>
+            <a:spLocks noGrp="1"/>
+          </p:cNvSpPr>
+          <p:nvPr/>
+        </p:nvSpPr>
+        <p:spPr>
+          <a:xfrm>
+            <a:off x="2724150" y="3562350"/>
+            <a:ext cx="0" cy="2362200"/>
+          </a:xfrm>
+          <a:prstGeom prst="line">
+            <a:avLst/>
+          </a:prstGeom>
+          <a:noFill/>
+          <a:ln w="0">
+            <a:noFill/>
+            <a:prstDash val="solid"/>
+          </a:ln>
+        </p:spPr>
+        <p:txBody>
+          <a:bodyPr/>
+          <a:lstStyle/>
+          <a:p>
+            <a:endParaRPr/>
+          </a:p>
+        </p:txBody>
+      </p:sp>
+      <p:sp>
+        <p:nvSpPr>
+          <p:cNvPr id="386" name="db-onboarding-config-line-across">
+            <a:extLst>
+              <a:ext uri="{FF2B5EF4-FFF2-40B4-BE49-F238E27FC236}">
+                <a16:creationId xmlns:a16="http://schemas.microsoft.com/office/drawing/2014/main" id="{2D27D158-DF4A-45DE-B519-55019BFC891C}"/>
+              </a:ext>
+            </a:extLst>
+          </p:cNvPr>
+          <p:cNvSpPr>
+            <a:spLocks noGrp="1"/>
+          </p:cNvSpPr>
+          <p:nvPr/>
+        </p:nvSpPr>
+        <p:spPr>
+          <a:xfrm>
+            <a:off x="2724150" y="3562350"/>
+            <a:ext cx="4467225" cy="0"/>
+          </a:xfrm>
+          <a:prstGeom prst="line">
+            <a:avLst/>
+          </a:prstGeom>
+          <a:noFill/>
+          <a:ln w="0">
+            <a:noFill/>
+            <a:prstDash val="solid"/>
+          </a:ln>
+        </p:spPr>
+        <p:txBody>
+          <a:bodyPr/>
+          <a:lstStyle/>
+          <a:p>
+            <a:endParaRPr/>
+          </a:p>
+        </p:txBody>
+      </p:sp>
+      <p:sp>
+        <p:nvSpPr>
+          <p:cNvPr id="387" name="db-onboarding-config-line-target">
+            <a:extLst>
+              <a:ext uri="{FF2B5EF4-FFF2-40B4-BE49-F238E27FC236}">
+                <a16:creationId xmlns:a16="http://schemas.microsoft.com/office/drawing/2014/main" id="{1B50F7BC-7603-4538-9AA7-EF7CE89682D0}"/>
+              </a:ext>
+            </a:extLst>
+          </p:cNvPr>
+          <p:cNvSpPr>
+            <a:spLocks noGrp="1"/>
+          </p:cNvSpPr>
+          <p:nvPr/>
+        </p:nvSpPr>
+        <p:spPr>
+          <a:xfrm>
+            <a:off x="7191375" y="3486150"/>
+            <a:ext cx="0" cy="76200"/>
+          </a:xfrm>
+          <a:prstGeom prst="line">
+            <a:avLst/>
+          </a:prstGeom>
+          <a:noFill/>
+          <a:ln w="0">
+            <a:noFill/>
+            <a:prstDash val="solid"/>
+          </a:ln>
+        </p:spPr>
+        <p:txBody>
+          <a:bodyPr/>
+          <a:lstStyle/>
+          <a:p>
+            <a:endParaRPr/>
+          </a:p>
+        </p:txBody>
+      </p:sp>
+      <p:sp>
+        <p:nvSpPr>
+          <p:cNvPr id="388" name="db-onboarding-config-arrow">
+            <a:extLst>
+              <a:ext uri="{FF2B5EF4-FFF2-40B4-BE49-F238E27FC236}">
+                <a16:creationId xmlns:a16="http://schemas.microsoft.com/office/drawing/2014/main" id="{6976FE11-B1EB-4E54-A54F-62A1FEB07123}"/>
+              </a:ext>
+            </a:extLst>
+          </p:cNvPr>
+          <p:cNvSpPr>
+            <a:spLocks noGrp="1"/>
+          </p:cNvSpPr>
+          <p:nvPr/>
+        </p:nvSpPr>
+        <p:spPr>
+          <a:xfrm>
+            <a:off x="7143750" y="3448050"/>
+            <a:ext cx="95250" cy="95250"/>
+          </a:xfrm>
+          <a:prstGeom prst="triangle">
+            <a:avLst/>
+          </a:prstGeom>
+          <a:noFill/>
+          <a:ln w="0">
+            <a:noFill/>
+            <a:prstDash val="solid"/>
+          </a:ln>
+        </p:spPr>
+        <p:txBody>
+          <a:bodyPr/>
+          <a:lstStyle/>
+          <a:p>
+            <a:endParaRPr/>
+          </a:p>
+        </p:txBody>
+      </p:sp>
+      <p:sp>
+        <p:nvSpPr>
+          <p:cNvPr id="521" name="db-onboarding-config-arrow-visible">
+            <a:extLst>
+              <a:ext uri="{FF2B5EF4-FFF2-40B4-BE49-F238E27FC236}">
+                <a16:creationId xmlns:a16="http://schemas.microsoft.com/office/drawing/2014/main" id="{23492FAB-510D-405A-B0B1-E0A4A4827EF1}"/>
+              </a:ext>
+            </a:extLst>
+          </p:cNvPr>
+          <p:cNvSpPr>
+            <a:spLocks noGrp="1"/>
+          </p:cNvSpPr>
+          <p:nvPr/>
+        </p:nvSpPr>
+        <p:spPr>
+          <a:xfrm>
+            <a:off x="7143750" y="3486150"/>
+            <a:ext cx="95250" cy="114300"/>
+          </a:xfrm>
+          <a:prstGeom prst="upArrow">
+            <a:avLst/>
+          </a:prstGeom>
+          <a:noFill/>
+          <a:ln w="0">
+            <a:noFill/>
+            <a:prstDash val="solid"/>
+          </a:ln>
+        </p:spPr>
+        <p:txBody>
+          <a:bodyPr/>
+          <a:lstStyle/>
+          <a:p>
+            <a:endParaRPr/>
           </a:p>
         </p:txBody>
       </p:sp>
@@ -5385,6 +4664,7 @@
           <a:lstStyle/>
           <a:p>
             <a:pPr algn="l">
+              <a:buNone/>
               <a:defRPr sz="975" b="1">
                 <a:solidFill>
                   <a:srgbClr val="1F77B4"/>
@@ -5435,6 +4715,7 @@
           <a:lstStyle/>
           <a:p>
             <a:pPr algn="l">
+              <a:buNone/>
               <a:defRPr sz="2850" b="1">
                 <a:solidFill>
                   <a:srgbClr val="132238"/>
@@ -5516,6 +4797,7 @@
           <a:lstStyle/>
           <a:p>
             <a:pPr algn="l">
+              <a:buNone/>
               <a:defRPr sz="900" b="0">
                 <a:solidFill>
                   <a:srgbClr val="7A8695"/>
@@ -5528,7 +4810,7 @@
                   <a:srgbClr val="7A8695"/>
                 </a:solidFill>
               </a:rPr>
-              <a:t>Autonomous AI Agents Case  |  3/5</a:t>
+              <a:t>Autonomous AI Agents Case  |  3/4</a:t>
             </a:r>
           </a:p>
         </p:txBody>
@@ -5599,6 +4881,7 @@
           <a:lstStyle/>
           <a:p>
             <a:pPr algn="l">
+              <a:buNone/>
               <a:defRPr sz="1800" b="1">
                 <a:solidFill>
                   <a:srgbClr val="132238"/>
@@ -5649,6 +4932,7 @@
           <a:lstStyle/>
           <a:p>
             <a:pPr algn="l">
+              <a:buNone/>
               <a:defRPr sz="1425" b="0">
                 <a:solidFill>
                   <a:srgbClr val="5E6B7A"/>
@@ -5732,6 +5016,7 @@
           <a:lstStyle/>
           <a:p>
             <a:pPr algn="l">
+              <a:buNone/>
               <a:defRPr sz="1800" b="1">
                 <a:solidFill>
                   <a:srgbClr val="132238"/>
@@ -5782,6 +5067,7 @@
           <a:lstStyle/>
           <a:p>
             <a:pPr algn="l">
+              <a:buNone/>
               <a:defRPr sz="1425" b="0">
                 <a:solidFill>
                   <a:srgbClr val="5E6B7A"/>
@@ -5865,6 +5151,7 @@
           <a:lstStyle/>
           <a:p>
             <a:pPr algn="l">
+              <a:buNone/>
               <a:defRPr sz="1800" b="1">
                 <a:solidFill>
                   <a:srgbClr val="132238"/>
@@ -5915,6 +5202,7 @@
           <a:lstStyle/>
           <a:p>
             <a:pPr algn="l">
+              <a:buNone/>
               <a:defRPr sz="1425" b="0">
                 <a:solidFill>
                   <a:srgbClr val="5E6B7A"/>
@@ -5998,6 +5286,7 @@
           <a:lstStyle/>
           <a:p>
             <a:pPr algn="l">
+              <a:buNone/>
               <a:defRPr sz="1800" b="1">
                 <a:solidFill>
                   <a:srgbClr val="132238"/>
@@ -6048,6 +5337,7 @@
           <a:lstStyle/>
           <a:p>
             <a:pPr algn="l">
+              <a:buNone/>
               <a:defRPr sz="1425" b="0">
                 <a:solidFill>
                   <a:srgbClr val="5E6B7A"/>
@@ -6131,6 +5421,7 @@
           <a:lstStyle/>
           <a:p>
             <a:pPr algn="l">
+              <a:buNone/>
               <a:defRPr sz="1800" b="1">
                 <a:solidFill>
                   <a:srgbClr val="132238"/>
@@ -6181,6 +5472,7 @@
           <a:lstStyle/>
           <a:p>
             <a:pPr algn="l">
+              <a:buNone/>
               <a:defRPr sz="1425" b="0">
                 <a:solidFill>
                   <a:srgbClr val="5E6B7A"/>
@@ -6269,10 +5561,10 @@
       </p:grpSpPr>
       <p:sp>
         <p:nvSpPr>
-          <p:cNvPr id="22" name="kicker">
-            <a:extLst>
-              <a:ext uri="{FF2B5EF4-FFF2-40B4-BE49-F238E27FC236}">
-                <a16:creationId xmlns:a16="http://schemas.microsoft.com/office/drawing/2014/main" id="{E0E80125-4656-4352-844D-C79559CEBA7D}"/>
+          <p:cNvPr id="33" name="kicker">
+            <a:extLst>
+              <a:ext uri="{FF2B5EF4-FFF2-40B4-BE49-F238E27FC236}">
+                <a16:creationId xmlns:a16="http://schemas.microsoft.com/office/drawing/2014/main" id="{46C7E236-16BD-4314-B9DF-605D6F71D9CF}"/>
               </a:ext>
             </a:extLst>
           </p:cNvPr>
@@ -6300,6 +5592,7 @@
           <a:lstStyle/>
           <a:p>
             <a:pPr algn="l">
+              <a:buNone/>
               <a:defRPr sz="975" b="1">
                 <a:solidFill>
                   <a:srgbClr val="1F77B4"/>
@@ -6322,7 +5615,7 @@
           <p:cNvPr id="2" name="title">
             <a:extLst>
               <a:ext uri="{FF2B5EF4-FFF2-40B4-BE49-F238E27FC236}">
-                <a16:creationId xmlns:a16="http://schemas.microsoft.com/office/drawing/2014/main" id="{64474222-B9D5-4333-9DAE-2F3316BF6034}"/>
+                <a16:creationId xmlns:a16="http://schemas.microsoft.com/office/drawing/2014/main" id="{68B89424-BFC3-4B1F-BFF1-DEA0F431D17E}"/>
               </a:ext>
             </a:extLst>
           </p:cNvPr>
@@ -6350,6 +5643,7 @@
           <a:lstStyle/>
           <a:p>
             <a:pPr algn="l">
+              <a:buNone/>
               <a:defRPr sz="2850" b="1">
                 <a:solidFill>
                   <a:srgbClr val="132238"/>
@@ -6362,7 +5656,7 @@
                   <a:srgbClr val="132238"/>
                 </a:solidFill>
               </a:rPr>
-              <a:t>The interface makes agent behavior visible</a:t>
+              <a:t>Evaluation and next steps</a:t>
             </a:r>
           </a:p>
         </p:txBody>
@@ -6372,7 +5666,7 @@
           <p:cNvPr id="3" name="header-rule">
             <a:extLst>
               <a:ext uri="{FF2B5EF4-FFF2-40B4-BE49-F238E27FC236}">
-                <a16:creationId xmlns:a16="http://schemas.microsoft.com/office/drawing/2014/main" id="{191497B2-C3BD-4D13-95D4-52725DFA9F54}"/>
+                <a16:creationId xmlns:a16="http://schemas.microsoft.com/office/drawing/2014/main" id="{2D77D10E-48A7-415B-BA45-53466B05BED8}"/>
               </a:ext>
             </a:extLst>
           </p:cNvPr>
@@ -6400,10 +5694,10 @@
       </p:sp>
       <p:sp>
         <p:nvSpPr>
-          <p:cNvPr id="4" name="footer-4">
-            <a:extLst>
-              <a:ext uri="{FF2B5EF4-FFF2-40B4-BE49-F238E27FC236}">
-                <a16:creationId xmlns:a16="http://schemas.microsoft.com/office/drawing/2014/main" id="{FC64F62B-9F65-4EF6-BF92-2CE3EB29509F}"/>
+          <p:cNvPr id="4" name="footer-5">
+            <a:extLst>
+              <a:ext uri="{FF2B5EF4-FFF2-40B4-BE49-F238E27FC236}">
+                <a16:creationId xmlns:a16="http://schemas.microsoft.com/office/drawing/2014/main" id="{ACBD6796-F9F0-47F8-B7A5-F5F7B6D0A75F}"/>
               </a:ext>
             </a:extLst>
           </p:cNvPr>
@@ -6431,6 +5725,7 @@
           <a:lstStyle/>
           <a:p>
             <a:pPr algn="l">
+              <a:buNone/>
               <a:defRPr sz="900" b="0">
                 <a:solidFill>
                   <a:srgbClr val="7A8695"/>
@@ -6443,615 +5738,135 @@
                   <a:srgbClr val="7A8695"/>
                 </a:solidFill>
               </a:rPr>
-              <a:t>Autonomous AI Agents Case  |  4/5</a:t>
-            </a:r>
-          </a:p>
-        </p:txBody>
-      </p:sp>
-      <p:sp>
-        <p:nvSpPr>
-          <p:cNvPr id="5" name="interface-copy">
-            <a:extLst>
-              <a:ext uri="{FF2B5EF4-FFF2-40B4-BE49-F238E27FC236}">
-                <a16:creationId xmlns:a16="http://schemas.microsoft.com/office/drawing/2014/main" id="{33234F98-5D55-4D31-B908-B37A30C09932}"/>
-              </a:ext>
-            </a:extLst>
-          </p:cNvPr>
-          <p:cNvSpPr>
-            <a:spLocks noGrp="1"/>
-          </p:cNvSpPr>
-          <p:nvPr/>
-        </p:nvSpPr>
-        <p:spPr>
-          <a:xfrm>
-            <a:off x="819150" y="1962150"/>
-            <a:ext cx="4095750" cy="723900"/>
-          </a:xfrm>
-          <a:prstGeom prst="rect">
-            <a:avLst/>
-          </a:prstGeom>
-          <a:noFill/>
-          <a:ln w="0">
-            <a:noFill/>
-            <a:prstDash val="solid"/>
-          </a:ln>
-        </p:spPr>
-        <p:txBody>
-          <a:bodyPr/>
-          <a:lstStyle/>
-          <a:p>
-            <a:pPr algn="l">
-              <a:defRPr sz="1650" b="0">
-                <a:solidFill>
-                  <a:srgbClr val="5E6B7A"/>
-                </a:solidFill>
-              </a:defRPr>
-            </a:pPr>
-            <a:r>
-              <a:rPr sz="1650" b="0">
-                <a:solidFill>
-                  <a:srgbClr val="5E6B7A"/>
-                </a:solidFill>
-              </a:rPr>
-              <a:t>The UI turns a technical agent pipeline into a controlled user workflow.</a:t>
-            </a:r>
-          </a:p>
-        </p:txBody>
-      </p:sp>
-      <p:sp>
-        <p:nvSpPr>
-          <p:cNvPr id="6" name="accent-Permission-aware">
-            <a:extLst>
-              <a:ext uri="{FF2B5EF4-FFF2-40B4-BE49-F238E27FC236}">
-                <a16:creationId xmlns:a16="http://schemas.microsoft.com/office/drawing/2014/main" id="{40026136-85F4-4D11-A43A-C0BE7B89EBB6}"/>
-              </a:ext>
-            </a:extLst>
-          </p:cNvPr>
-          <p:cNvSpPr>
-            <a:spLocks noGrp="1"/>
-          </p:cNvSpPr>
-          <p:nvPr/>
-        </p:nvSpPr>
-        <p:spPr>
-          <a:xfrm>
-            <a:off x="876300" y="3028950"/>
-            <a:ext cx="47625" cy="323850"/>
-          </a:xfrm>
-          <a:prstGeom prst="rect">
-            <a:avLst/>
-          </a:prstGeom>
-          <a:solidFill>
-            <a:srgbClr val="1F77B4"/>
-          </a:solidFill>
-          <a:ln w="0">
-            <a:solidFill>
-              <a:srgbClr val="1F77B4"/>
-            </a:solidFill>
-            <a:prstDash val="solid"/>
-          </a:ln>
-        </p:spPr>
-      </p:sp>
-      <p:sp>
-        <p:nvSpPr>
-          <p:cNvPr id="7" name="label-Permission-aware">
-            <a:extLst>
-              <a:ext uri="{FF2B5EF4-FFF2-40B4-BE49-F238E27FC236}">
-                <a16:creationId xmlns:a16="http://schemas.microsoft.com/office/drawing/2014/main" id="{56EC452C-620D-49A7-9EA3-7D47C262D804}"/>
-              </a:ext>
-            </a:extLst>
-          </p:cNvPr>
-          <p:cNvSpPr>
-            <a:spLocks noGrp="1"/>
-          </p:cNvSpPr>
-          <p:nvPr/>
-        </p:nvSpPr>
-        <p:spPr>
-          <a:xfrm>
-            <a:off x="1028700" y="2990850"/>
-            <a:ext cx="3619500" cy="419100"/>
-          </a:xfrm>
-          <a:prstGeom prst="rect">
-            <a:avLst/>
-          </a:prstGeom>
-          <a:noFill/>
-          <a:ln w="0">
-            <a:noFill/>
-            <a:prstDash val="solid"/>
-          </a:ln>
-        </p:spPr>
-        <p:txBody>
-          <a:bodyPr/>
-          <a:lstStyle/>
-          <a:p>
-            <a:pPr algn="l">
-              <a:defRPr sz="1800" b="1">
+              <a:t>Autonomous AI Agents Case  |  4/4</a:t>
+            </a:r>
+          </a:p>
+        </p:txBody>
+      </p:sp>
+      <p:sp>
+        <p:nvSpPr>
+          <p:cNvPr id="5" name="tests-number">
+            <a:extLst>
+              <a:ext uri="{FF2B5EF4-FFF2-40B4-BE49-F238E27FC236}">
+                <a16:creationId xmlns:a16="http://schemas.microsoft.com/office/drawing/2014/main" id="{0509A4D8-11B5-41FD-9B22-2306B41B9E1C}"/>
+              </a:ext>
+            </a:extLst>
+          </p:cNvPr>
+          <p:cNvSpPr>
+            <a:spLocks noGrp="1"/>
+          </p:cNvSpPr>
+          <p:nvPr/>
+        </p:nvSpPr>
+        <p:spPr>
+          <a:xfrm>
+            <a:off x="819150" y="2133600"/>
+            <a:ext cx="2000250" cy="876300"/>
+          </a:xfrm>
+          <a:prstGeom prst="rect">
+            <a:avLst/>
+          </a:prstGeom>
+          <a:noFill/>
+          <a:ln w="0">
+            <a:noFill/>
+            <a:prstDash val="solid"/>
+          </a:ln>
+        </p:spPr>
+        <p:txBody>
+          <a:bodyPr/>
+          <a:lstStyle/>
+          <a:p>
+            <a:pPr algn="ctr">
+              <a:buNone/>
+              <a:defRPr sz="5700" b="1">
+                <a:solidFill>
+                  <a:srgbClr val="1F77B4"/>
+                </a:solidFill>
+              </a:defRPr>
+            </a:pPr>
+            <a:r>
+              <a:rPr sz="5700" b="1">
+                <a:solidFill>
+                  <a:srgbClr val="1F77B4"/>
+                </a:solidFill>
+              </a:rPr>
+              <a:t>24</a:t>
+            </a:r>
+          </a:p>
+        </p:txBody>
+      </p:sp>
+      <p:sp>
+        <p:nvSpPr>
+          <p:cNvPr id="6" name="tests-label">
+            <a:extLst>
+              <a:ext uri="{FF2B5EF4-FFF2-40B4-BE49-F238E27FC236}">
+                <a16:creationId xmlns:a16="http://schemas.microsoft.com/office/drawing/2014/main" id="{3345D74B-B422-4BB7-94A4-0270E99B60AE}"/>
+              </a:ext>
+            </a:extLst>
+          </p:cNvPr>
+          <p:cNvSpPr>
+            <a:spLocks noGrp="1"/>
+          </p:cNvSpPr>
+          <p:nvPr/>
+        </p:nvSpPr>
+        <p:spPr>
+          <a:xfrm>
+            <a:off x="781050" y="3009900"/>
+            <a:ext cx="2190750" cy="514350"/>
+          </a:xfrm>
+          <a:prstGeom prst="rect">
+            <a:avLst/>
+          </a:prstGeom>
+          <a:noFill/>
+          <a:ln w="0">
+            <a:noFill/>
+            <a:prstDash val="solid"/>
+          </a:ln>
+        </p:spPr>
+        <p:txBody>
+          <a:bodyPr/>
+          <a:lstStyle/>
+          <a:p>
+            <a:pPr algn="ctr">
+              <a:buNone/>
+              <a:defRPr sz="1650" b="1">
                 <a:solidFill>
                   <a:srgbClr val="132238"/>
                 </a:solidFill>
               </a:defRPr>
             </a:pPr>
             <a:r>
-              <a:rPr sz="1800" b="1">
+              <a:rPr sz="1650" b="1">
                 <a:solidFill>
                   <a:srgbClr val="132238"/>
                 </a:solidFill>
               </a:rPr>
-              <a:t>Permission-aware</a:t>
-            </a:r>
-          </a:p>
-        </p:txBody>
-      </p:sp>
-      <p:sp>
-        <p:nvSpPr>
-          <p:cNvPr id="8" name="experience-body-0">
-            <a:extLst>
-              <a:ext uri="{FF2B5EF4-FFF2-40B4-BE49-F238E27FC236}">
-                <a16:creationId xmlns:a16="http://schemas.microsoft.com/office/drawing/2014/main" id="{0D57F4BF-109C-4EE9-99C0-8B24FB9F9014}"/>
-              </a:ext>
-            </a:extLst>
-          </p:cNvPr>
-          <p:cNvSpPr>
-            <a:spLocks noGrp="1"/>
-          </p:cNvSpPr>
-          <p:nvPr/>
-        </p:nvSpPr>
-        <p:spPr>
-          <a:xfrm>
-            <a:off x="1028700" y="3371850"/>
-            <a:ext cx="4000500" cy="304800"/>
-          </a:xfrm>
-          <a:prstGeom prst="rect">
-            <a:avLst/>
-          </a:prstGeom>
-          <a:noFill/>
-          <a:ln w="0">
-            <a:noFill/>
-            <a:prstDash val="solid"/>
-          </a:ln>
-        </p:spPr>
-        <p:txBody>
-          <a:bodyPr/>
-          <a:lstStyle/>
-          <a:p>
-            <a:pPr algn="l">
-              <a:defRPr sz="1275" b="0">
-                <a:solidFill>
-                  <a:srgbClr val="5E6B7A"/>
-                </a:solidFill>
-              </a:defRPr>
-            </a:pPr>
-            <a:r>
-              <a:rPr sz="1275" b="0">
-                <a:solidFill>
-                  <a:srgbClr val="5E6B7A"/>
-                </a:solidFill>
-              </a:rPr>
-              <a:t>Users only see authorized databases.</a:t>
-            </a:r>
-          </a:p>
-        </p:txBody>
-      </p:sp>
-      <p:sp>
-        <p:nvSpPr>
-          <p:cNvPr id="9" name="accent-Controllable">
-            <a:extLst>
-              <a:ext uri="{FF2B5EF4-FFF2-40B4-BE49-F238E27FC236}">
-                <a16:creationId xmlns:a16="http://schemas.microsoft.com/office/drawing/2014/main" id="{6E2928E0-F524-452C-8567-C976AD7662BD}"/>
-              </a:ext>
-            </a:extLst>
-          </p:cNvPr>
-          <p:cNvSpPr>
-            <a:spLocks noGrp="1"/>
-          </p:cNvSpPr>
-          <p:nvPr/>
-        </p:nvSpPr>
-        <p:spPr>
-          <a:xfrm>
-            <a:off x="876300" y="3657600"/>
-            <a:ext cx="47625" cy="323850"/>
-          </a:xfrm>
-          <a:prstGeom prst="rect">
-            <a:avLst/>
-          </a:prstGeom>
-          <a:solidFill>
-            <a:srgbClr val="FF7F0E"/>
-          </a:solidFill>
-          <a:ln w="0">
-            <a:solidFill>
-              <a:srgbClr val="FF7F0E"/>
-            </a:solidFill>
-            <a:prstDash val="solid"/>
-          </a:ln>
-        </p:spPr>
-      </p:sp>
-      <p:sp>
-        <p:nvSpPr>
-          <p:cNvPr id="10" name="label-Controllable">
-            <a:extLst>
-              <a:ext uri="{FF2B5EF4-FFF2-40B4-BE49-F238E27FC236}">
-                <a16:creationId xmlns:a16="http://schemas.microsoft.com/office/drawing/2014/main" id="{C0AC0AFE-156A-4AD0-A3B6-5E67C23A2444}"/>
-              </a:ext>
-            </a:extLst>
-          </p:cNvPr>
-          <p:cNvSpPr>
-            <a:spLocks noGrp="1"/>
-          </p:cNvSpPr>
-          <p:nvPr/>
-        </p:nvSpPr>
-        <p:spPr>
-          <a:xfrm>
-            <a:off x="1028700" y="3619500"/>
-            <a:ext cx="3619500" cy="419100"/>
-          </a:xfrm>
-          <a:prstGeom prst="rect">
-            <a:avLst/>
-          </a:prstGeom>
-          <a:noFill/>
-          <a:ln w="0">
-            <a:noFill/>
-            <a:prstDash val="solid"/>
-          </a:ln>
-        </p:spPr>
-        <p:txBody>
-          <a:bodyPr/>
-          <a:lstStyle/>
-          <a:p>
-            <a:pPr algn="l">
-              <a:defRPr sz="1800" b="1">
-                <a:solidFill>
-                  <a:srgbClr val="132238"/>
-                </a:solidFill>
-              </a:defRPr>
-            </a:pPr>
-            <a:r>
-              <a:rPr sz="1800" b="1">
-                <a:solidFill>
-                  <a:srgbClr val="132238"/>
-                </a:solidFill>
-              </a:rPr>
-              <a:t>Controllable</a:t>
-            </a:r>
-          </a:p>
-        </p:txBody>
-      </p:sp>
-      <p:sp>
-        <p:nvSpPr>
-          <p:cNvPr id="11" name="experience-body-1">
-            <a:extLst>
-              <a:ext uri="{FF2B5EF4-FFF2-40B4-BE49-F238E27FC236}">
-                <a16:creationId xmlns:a16="http://schemas.microsoft.com/office/drawing/2014/main" id="{76D25259-ACD9-4003-9714-850ACD10C3EA}"/>
-              </a:ext>
-            </a:extLst>
-          </p:cNvPr>
-          <p:cNvSpPr>
-            <a:spLocks noGrp="1"/>
-          </p:cNvSpPr>
-          <p:nvPr/>
-        </p:nvSpPr>
-        <p:spPr>
-          <a:xfrm>
-            <a:off x="1028700" y="4000500"/>
-            <a:ext cx="4000500" cy="304800"/>
-          </a:xfrm>
-          <a:prstGeom prst="rect">
-            <a:avLst/>
-          </a:prstGeom>
-          <a:noFill/>
-          <a:ln w="0">
-            <a:noFill/>
-            <a:prstDash val="solid"/>
-          </a:ln>
-        </p:spPr>
-        <p:txBody>
-          <a:bodyPr/>
-          <a:lstStyle/>
-          <a:p>
-            <a:pPr algn="l">
-              <a:defRPr sz="1275" b="0">
-                <a:solidFill>
-                  <a:srgbClr val="5E6B7A"/>
-                </a:solidFill>
-              </a:defRPr>
-            </a:pPr>
-            <a:r>
-              <a:rPr sz="1275" b="0">
-                <a:solidFill>
-                  <a:srgbClr val="5E6B7A"/>
-                </a:solidFill>
-              </a:rPr>
-              <a:t>Mode, chart, row limit, and preview size are explicit.</a:t>
-            </a:r>
-          </a:p>
-        </p:txBody>
-      </p:sp>
-      <p:sp>
-        <p:nvSpPr>
-          <p:cNvPr id="12" name="accent-Transparent">
-            <a:extLst>
-              <a:ext uri="{FF2B5EF4-FFF2-40B4-BE49-F238E27FC236}">
-                <a16:creationId xmlns:a16="http://schemas.microsoft.com/office/drawing/2014/main" id="{CDE9809C-5791-4DC5-8ACD-7DFE89985511}"/>
-              </a:ext>
-            </a:extLst>
-          </p:cNvPr>
-          <p:cNvSpPr>
-            <a:spLocks noGrp="1"/>
-          </p:cNvSpPr>
-          <p:nvPr/>
-        </p:nvSpPr>
-        <p:spPr>
-          <a:xfrm>
-            <a:off x="876300" y="4286250"/>
-            <a:ext cx="47625" cy="323850"/>
-          </a:xfrm>
-          <a:prstGeom prst="rect">
-            <a:avLst/>
-          </a:prstGeom>
-          <a:solidFill>
-            <a:srgbClr val="1F77B4"/>
-          </a:solidFill>
-          <a:ln w="0">
-            <a:solidFill>
-              <a:srgbClr val="1F77B4"/>
-            </a:solidFill>
-            <a:prstDash val="solid"/>
-          </a:ln>
-        </p:spPr>
-      </p:sp>
-      <p:sp>
-        <p:nvSpPr>
-          <p:cNvPr id="13" name="label-Transparent">
-            <a:extLst>
-              <a:ext uri="{FF2B5EF4-FFF2-40B4-BE49-F238E27FC236}">
-                <a16:creationId xmlns:a16="http://schemas.microsoft.com/office/drawing/2014/main" id="{8CEFAB88-0C89-4859-A052-F2B4795ADCDF}"/>
-              </a:ext>
-            </a:extLst>
-          </p:cNvPr>
-          <p:cNvSpPr>
-            <a:spLocks noGrp="1"/>
-          </p:cNvSpPr>
-          <p:nvPr/>
-        </p:nvSpPr>
-        <p:spPr>
-          <a:xfrm>
-            <a:off x="1028700" y="4248150"/>
-            <a:ext cx="3619500" cy="419100"/>
-          </a:xfrm>
-          <a:prstGeom prst="rect">
-            <a:avLst/>
-          </a:prstGeom>
-          <a:noFill/>
-          <a:ln w="0">
-            <a:noFill/>
-            <a:prstDash val="solid"/>
-          </a:ln>
-        </p:spPr>
-        <p:txBody>
-          <a:bodyPr/>
-          <a:lstStyle/>
-          <a:p>
-            <a:pPr algn="l">
-              <a:defRPr sz="1800" b="1">
-                <a:solidFill>
-                  <a:srgbClr val="132238"/>
-                </a:solidFill>
-              </a:defRPr>
-            </a:pPr>
-            <a:r>
-              <a:rPr sz="1800" b="1">
-                <a:solidFill>
-                  <a:srgbClr val="132238"/>
-                </a:solidFill>
-              </a:rPr>
-              <a:t>Transparent</a:t>
-            </a:r>
-          </a:p>
-        </p:txBody>
-      </p:sp>
-      <p:sp>
-        <p:nvSpPr>
-          <p:cNvPr id="14" name="experience-body-2">
-            <a:extLst>
-              <a:ext uri="{FF2B5EF4-FFF2-40B4-BE49-F238E27FC236}">
-                <a16:creationId xmlns:a16="http://schemas.microsoft.com/office/drawing/2014/main" id="{1D9DB0FD-C61F-4E2F-BCFC-B25D50EFD58F}"/>
-              </a:ext>
-            </a:extLst>
-          </p:cNvPr>
-          <p:cNvSpPr>
-            <a:spLocks noGrp="1"/>
-          </p:cNvSpPr>
-          <p:nvPr/>
-        </p:nvSpPr>
-        <p:spPr>
-          <a:xfrm>
-            <a:off x="1028700" y="4629150"/>
-            <a:ext cx="4000500" cy="304800"/>
-          </a:xfrm>
-          <a:prstGeom prst="rect">
-            <a:avLst/>
-          </a:prstGeom>
-          <a:noFill/>
-          <a:ln w="0">
-            <a:noFill/>
-            <a:prstDash val="solid"/>
-          </a:ln>
-        </p:spPr>
-        <p:txBody>
-          <a:bodyPr/>
-          <a:lstStyle/>
-          <a:p>
-            <a:pPr algn="l">
-              <a:defRPr sz="1275" b="0">
-                <a:solidFill>
-                  <a:srgbClr val="5E6B7A"/>
-                </a:solidFill>
-              </a:defRPr>
-            </a:pPr>
-            <a:r>
-              <a:rPr sz="1275" b="0">
-                <a:solidFill>
-                  <a:srgbClr val="5E6B7A"/>
-                </a:solidFill>
-              </a:rPr>
-              <a:t>Status, SQL, summary, data, chart, and files are shown.</a:t>
-            </a:r>
-          </a:p>
-        </p:txBody>
-      </p:sp>
-      <p:sp>
-        <p:nvSpPr>
-          <p:cNvPr id="15" name="accent-Admin-ready">
-            <a:extLst>
-              <a:ext uri="{FF2B5EF4-FFF2-40B4-BE49-F238E27FC236}">
-                <a16:creationId xmlns:a16="http://schemas.microsoft.com/office/drawing/2014/main" id="{1D5E00ED-790E-47B3-B5E2-5C9C2CA5645F}"/>
-              </a:ext>
-            </a:extLst>
-          </p:cNvPr>
-          <p:cNvSpPr>
-            <a:spLocks noGrp="1"/>
-          </p:cNvSpPr>
-          <p:nvPr/>
-        </p:nvSpPr>
-        <p:spPr>
-          <a:xfrm>
-            <a:off x="876300" y="4914900"/>
-            <a:ext cx="47625" cy="323850"/>
-          </a:xfrm>
-          <a:prstGeom prst="rect">
-            <a:avLst/>
-          </a:prstGeom>
-          <a:solidFill>
-            <a:srgbClr val="1F77B4"/>
-          </a:solidFill>
-          <a:ln w="0">
-            <a:solidFill>
-              <a:srgbClr val="1F77B4"/>
-            </a:solidFill>
-            <a:prstDash val="solid"/>
-          </a:ln>
-        </p:spPr>
-      </p:sp>
-      <p:sp>
-        <p:nvSpPr>
-          <p:cNvPr id="16" name="label-Admin-ready">
-            <a:extLst>
-              <a:ext uri="{FF2B5EF4-FFF2-40B4-BE49-F238E27FC236}">
-                <a16:creationId xmlns:a16="http://schemas.microsoft.com/office/drawing/2014/main" id="{59D23EC9-CE17-425A-A5E4-C1CAE59FA93B}"/>
-              </a:ext>
-            </a:extLst>
-          </p:cNvPr>
-          <p:cNvSpPr>
-            <a:spLocks noGrp="1"/>
-          </p:cNvSpPr>
-          <p:nvPr/>
-        </p:nvSpPr>
-        <p:spPr>
-          <a:xfrm>
-            <a:off x="1028700" y="4876800"/>
-            <a:ext cx="3619500" cy="419100"/>
-          </a:xfrm>
-          <a:prstGeom prst="rect">
-            <a:avLst/>
-          </a:prstGeom>
-          <a:noFill/>
-          <a:ln w="0">
-            <a:noFill/>
-            <a:prstDash val="solid"/>
-          </a:ln>
-        </p:spPr>
-        <p:txBody>
-          <a:bodyPr/>
-          <a:lstStyle/>
-          <a:p>
-            <a:pPr algn="l">
-              <a:defRPr sz="1800" b="1">
-                <a:solidFill>
-                  <a:srgbClr val="132238"/>
-                </a:solidFill>
-              </a:defRPr>
-            </a:pPr>
-            <a:r>
-              <a:rPr sz="1800" b="1">
-                <a:solidFill>
-                  <a:srgbClr val="132238"/>
-                </a:solidFill>
-              </a:rPr>
-              <a:t>Admin-ready</a:t>
-            </a:r>
-          </a:p>
-        </p:txBody>
-      </p:sp>
-      <p:sp>
-        <p:nvSpPr>
-          <p:cNvPr id="17" name="experience-body-3">
-            <a:extLst>
-              <a:ext uri="{FF2B5EF4-FFF2-40B4-BE49-F238E27FC236}">
-                <a16:creationId xmlns:a16="http://schemas.microsoft.com/office/drawing/2014/main" id="{0C98F368-7C90-418E-A25B-677ED8FB4AE0}"/>
-              </a:ext>
-            </a:extLst>
-          </p:cNvPr>
-          <p:cNvSpPr>
-            <a:spLocks noGrp="1"/>
-          </p:cNvSpPr>
-          <p:nvPr/>
-        </p:nvSpPr>
-        <p:spPr>
-          <a:xfrm>
-            <a:off x="1028700" y="5257800"/>
-            <a:ext cx="4000500" cy="304800"/>
-          </a:xfrm>
-          <a:prstGeom prst="rect">
-            <a:avLst/>
-          </a:prstGeom>
-          <a:noFill/>
-          <a:ln w="0">
-            <a:noFill/>
-            <a:prstDash val="solid"/>
-          </a:ln>
-        </p:spPr>
-        <p:txBody>
-          <a:bodyPr/>
-          <a:lstStyle/>
-          <a:p>
-            <a:pPr algn="l">
-              <a:defRPr sz="1275" b="0">
-                <a:solidFill>
-                  <a:srgbClr val="5E6B7A"/>
-                </a:solidFill>
-              </a:defRPr>
-            </a:pPr>
-            <a:r>
-              <a:rPr sz="1275" b="0">
-                <a:solidFill>
-                  <a:srgbClr val="5E6B7A"/>
-                </a:solidFill>
-              </a:rPr>
-              <a:t>Add users and SQLite databases in the sidebar.</a:t>
-            </a:r>
-          </a:p>
-        </p:txBody>
-      </p:sp>
-      <p:sp>
-        <p:nvSpPr>
-          <p:cNvPr id="18" name="ui-screenshot-placeholder">
-            <a:extLst>
-              <a:ext uri="{FF2B5EF4-FFF2-40B4-BE49-F238E27FC236}">
-                <a16:creationId xmlns:a16="http://schemas.microsoft.com/office/drawing/2014/main" id="{4738998C-5FBD-4417-BA7D-6B359C8E54CC}"/>
-              </a:ext>
-            </a:extLst>
-          </p:cNvPr>
-          <p:cNvSpPr>
-            <a:spLocks noGrp="1"/>
-          </p:cNvSpPr>
-          <p:nvPr/>
-        </p:nvSpPr>
-        <p:spPr>
-          <a:xfrm>
-            <a:off x="5983489" y="1619249"/>
-            <a:ext cx="5572317" cy="4523795"/>
+              <a:t>pytest tests passing</a:t>
+            </a:r>
+          </a:p>
+        </p:txBody>
+      </p:sp>
+      <p:sp>
+        <p:nvSpPr>
+          <p:cNvPr id="7" name="metric-pass-rate">
+            <a:extLst>
+              <a:ext uri="{FF2B5EF4-FFF2-40B4-BE49-F238E27FC236}">
+                <a16:creationId xmlns:a16="http://schemas.microsoft.com/office/drawing/2014/main" id="{3D073007-05FA-4580-8DBA-D0E5A5B9A79A}"/>
+              </a:ext>
+            </a:extLst>
+          </p:cNvPr>
+          <p:cNvSpPr>
+            <a:spLocks noGrp="1"/>
+          </p:cNvSpPr>
+          <p:nvPr/>
+        </p:nvSpPr>
+        <p:spPr>
+          <a:xfrm>
+            <a:off x="781050" y="3733800"/>
+            <a:ext cx="1790700" cy="723900"/>
           </a:xfrm>
           <a:prstGeom prst="roundRect">
             <a:avLst>
-              <a:gd name="adj" fmla="val 4403"/>
+              <a:gd name="adj" fmla="val 18421"/>
             </a:avLst>
           </a:prstGeom>
           <a:solidFill>
@@ -7067,540 +5882,6 @@
       </p:sp>
       <p:sp>
         <p:nvSpPr>
-          <p:cNvPr id="19" name="ui-screenshot-placeholder-title">
-            <a:extLst>
-              <a:ext uri="{FF2B5EF4-FFF2-40B4-BE49-F238E27FC236}">
-                <a16:creationId xmlns:a16="http://schemas.microsoft.com/office/drawing/2014/main" id="{0E3C8E9D-4DDC-4C27-BB13-D18176F341DE}"/>
-              </a:ext>
-            </a:extLst>
-          </p:cNvPr>
-          <p:cNvSpPr>
-            <a:spLocks noGrp="1"/>
-          </p:cNvSpPr>
-          <p:nvPr/>
-        </p:nvSpPr>
-        <p:spPr>
-          <a:xfrm>
-            <a:off x="6457950" y="2343150"/>
-            <a:ext cx="4324350" cy="323850"/>
-          </a:xfrm>
-          <a:prstGeom prst="rect">
-            <a:avLst/>
-          </a:prstGeom>
-          <a:noFill/>
-          <a:ln w="0">
-            <a:noFill/>
-            <a:prstDash val="solid"/>
-          </a:ln>
-        </p:spPr>
-        <p:txBody>
-          <a:bodyPr/>
-          <a:lstStyle/>
-          <a:p>
-            <a:pPr algn="ctr">
-              <a:defRPr sz="1650" b="1">
-                <a:solidFill>
-                  <a:srgbClr val="132238"/>
-                </a:solidFill>
-              </a:defRPr>
-            </a:pPr>
-            <a:endParaRPr sz="1650" b="1" dirty="0">
-              <a:solidFill>
-                <a:srgbClr val="132238"/>
-              </a:solidFill>
-            </a:endParaRPr>
-          </a:p>
-        </p:txBody>
-      </p:sp>
-      <p:sp>
-        <p:nvSpPr>
-          <p:cNvPr id="20" name="ui-screenshot-placeholder-subtitle">
-            <a:extLst>
-              <a:ext uri="{FF2B5EF4-FFF2-40B4-BE49-F238E27FC236}">
-                <a16:creationId xmlns:a16="http://schemas.microsoft.com/office/drawing/2014/main" id="{2FADE6A5-6896-4C9E-8035-2C2798F592A6}"/>
-              </a:ext>
-            </a:extLst>
-          </p:cNvPr>
-          <p:cNvSpPr>
-            <a:spLocks noGrp="1"/>
-          </p:cNvSpPr>
-          <p:nvPr/>
-        </p:nvSpPr>
-        <p:spPr>
-          <a:xfrm>
-            <a:off x="6591300" y="3438525"/>
-            <a:ext cx="4057650" cy="495300"/>
-          </a:xfrm>
-          <a:prstGeom prst="rect">
-            <a:avLst/>
-          </a:prstGeom>
-          <a:noFill/>
-          <a:ln w="0">
-            <a:noFill/>
-            <a:prstDash val="solid"/>
-          </a:ln>
-        </p:spPr>
-        <p:txBody>
-          <a:bodyPr/>
-          <a:lstStyle/>
-          <a:p>
-            <a:pPr algn="ctr">
-              <a:defRPr sz="1350" b="0">
-                <a:solidFill>
-                  <a:srgbClr val="5E6B7A"/>
-                </a:solidFill>
-              </a:defRPr>
-            </a:pPr>
-            <a:endParaRPr sz="1350" b="0" dirty="0">
-              <a:solidFill>
-                <a:srgbClr val="5E6B7A"/>
-              </a:solidFill>
-            </a:endParaRPr>
-          </a:p>
-        </p:txBody>
-      </p:sp>
-      <p:sp>
-        <p:nvSpPr>
-          <p:cNvPr id="21" name="cli-note">
-            <a:extLst>
-              <a:ext uri="{FF2B5EF4-FFF2-40B4-BE49-F238E27FC236}">
-                <a16:creationId xmlns:a16="http://schemas.microsoft.com/office/drawing/2014/main" id="{AEFE7F61-93F6-425D-8A73-9F1E4F870433}"/>
-              </a:ext>
-            </a:extLst>
-          </p:cNvPr>
-          <p:cNvSpPr>
-            <a:spLocks noGrp="1"/>
-          </p:cNvSpPr>
-          <p:nvPr/>
-        </p:nvSpPr>
-        <p:spPr>
-          <a:xfrm>
-            <a:off x="6031690" y="6248400"/>
-            <a:ext cx="4857750" cy="381000"/>
-          </a:xfrm>
-          <a:prstGeom prst="rect">
-            <a:avLst/>
-          </a:prstGeom>
-          <a:noFill/>
-          <a:ln w="0">
-            <a:noFill/>
-            <a:prstDash val="solid"/>
-          </a:ln>
-        </p:spPr>
-        <p:txBody>
-          <a:bodyPr/>
-          <a:lstStyle/>
-          <a:p>
-            <a:pPr algn="ctr">
-              <a:defRPr sz="1500" b="1">
-                <a:solidFill>
-                  <a:srgbClr val="132238"/>
-                </a:solidFill>
-              </a:defRPr>
-            </a:pPr>
-            <a:r>
-              <a:rPr sz="1500" b="1" dirty="0">
-                <a:solidFill>
-                  <a:srgbClr val="132238"/>
-                </a:solidFill>
-              </a:rPr>
-              <a:t>CLI mirrors the same core controls for reproducible runs.</a:t>
-            </a:r>
-          </a:p>
-        </p:txBody>
-      </p:sp>
-      <p:pic>
-        <p:nvPicPr>
-          <p:cNvPr id="24" name="图片 23">
-            <a:extLst>
-              <a:ext uri="{FF2B5EF4-FFF2-40B4-BE49-F238E27FC236}">
-                <a16:creationId xmlns:a16="http://schemas.microsoft.com/office/drawing/2014/main" id="{5BAB0A42-64CA-6E02-E5BB-E8389AADB1DD}"/>
-              </a:ext>
-            </a:extLst>
-          </p:cNvPr>
-          <p:cNvPicPr>
-            <a:picLocks noChangeAspect="1"/>
-          </p:cNvPicPr>
-          <p:nvPr/>
-        </p:nvPicPr>
-        <p:blipFill>
-          <a:blip r:embed="rId3">
-            <a:extLst>
-              <a:ext uri="{28A0092B-C50C-407E-A947-70E740481C1C}">
-                <a14:useLocalDpi xmlns:a14="http://schemas.microsoft.com/office/drawing/2010/main" val="0"/>
-              </a:ext>
-            </a:extLst>
-          </a:blip>
-          <a:stretch>
-            <a:fillRect/>
-          </a:stretch>
-        </p:blipFill>
-        <p:spPr>
-          <a:xfrm>
-            <a:off x="6348312" y="1667457"/>
-            <a:ext cx="4842670" cy="4427783"/>
-          </a:xfrm>
-          <a:prstGeom prst="rect">
-            <a:avLst/>
-          </a:prstGeom>
-        </p:spPr>
-      </p:pic>
-    </p:spTree>
-    <p:extLst>
-      <p:ext uri="{BB962C8B-B14F-4D97-AF65-F5344CB8AC3E}">
-        <p14:creationId xmlns:p14="http://schemas.microsoft.com/office/powerpoint/2010/main" val="647275488"/>
-      </p:ext>
-    </p:extLst>
-  </p:cSld>
-  <p:clrMapOvr>
-    <a:masterClrMapping/>
-  </p:clrMapOvr>
-</p:sld>
-</file>
-
-<file path=ppt/slides/slide5.xml><?xml version="1.0" encoding="utf-8"?>
-<p:sld xmlns:a="http://schemas.openxmlformats.org/drawingml/2006/main" xmlns:r="http://schemas.openxmlformats.org/officeDocument/2006/relationships" xmlns:p="http://schemas.openxmlformats.org/presentationml/2006/main">
-  <p:cSld>
-    <p:bg>
-      <p:bgPr>
-        <a:solidFill>
-          <a:srgbClr val="FFFFFF"/>
-        </a:solidFill>
-        <a:effectLst/>
-      </p:bgPr>
-    </p:bg>
-    <p:spTree>
-      <p:nvGrpSpPr>
-        <p:cNvPr id="1" name=""/>
-        <p:cNvGrpSpPr/>
-        <p:nvPr/>
-      </p:nvGrpSpPr>
-      <p:grpSpPr>
-        <a:xfrm>
-          <a:off x="0" y="0"/>
-          <a:ext cx="0" cy="0"/>
-          <a:chOff x="0" y="0"/>
-          <a:chExt cx="0" cy="0"/>
-        </a:xfrm>
-      </p:grpSpPr>
-      <p:sp>
-        <p:nvSpPr>
-          <p:cNvPr id="33" name="kicker">
-            <a:extLst>
-              <a:ext uri="{FF2B5EF4-FFF2-40B4-BE49-F238E27FC236}">
-                <a16:creationId xmlns:a16="http://schemas.microsoft.com/office/drawing/2014/main" id="{46C7E236-16BD-4314-B9DF-605D6F71D9CF}"/>
-              </a:ext>
-            </a:extLst>
-          </p:cNvPr>
-          <p:cNvSpPr>
-            <a:spLocks noGrp="1"/>
-          </p:cNvSpPr>
-          <p:nvPr/>
-        </p:nvSpPr>
-        <p:spPr>
-          <a:xfrm>
-            <a:off x="685800" y="457200"/>
-            <a:ext cx="4000500" cy="247650"/>
-          </a:xfrm>
-          <a:prstGeom prst="rect">
-            <a:avLst/>
-          </a:prstGeom>
-          <a:noFill/>
-          <a:ln w="0">
-            <a:noFill/>
-            <a:prstDash val="solid"/>
-          </a:ln>
-        </p:spPr>
-        <p:txBody>
-          <a:bodyPr/>
-          <a:lstStyle/>
-          <a:p>
-            <a:pPr algn="l">
-              <a:defRPr sz="975" b="1">
-                <a:solidFill>
-                  <a:srgbClr val="1F77B4"/>
-                </a:solidFill>
-              </a:defRPr>
-            </a:pPr>
-            <a:r>
-              <a:rPr sz="975" b="1">
-                <a:solidFill>
-                  <a:srgbClr val="1F77B4"/>
-                </a:solidFill>
-              </a:rPr>
-              <a:t>AI TALENT LAB CASE</a:t>
-            </a:r>
-          </a:p>
-        </p:txBody>
-      </p:sp>
-      <p:sp>
-        <p:nvSpPr>
-          <p:cNvPr id="2" name="title">
-            <a:extLst>
-              <a:ext uri="{FF2B5EF4-FFF2-40B4-BE49-F238E27FC236}">
-                <a16:creationId xmlns:a16="http://schemas.microsoft.com/office/drawing/2014/main" id="{68B89424-BFC3-4B1F-BFF1-DEA0F431D17E}"/>
-              </a:ext>
-            </a:extLst>
-          </p:cNvPr>
-          <p:cNvSpPr>
-            <a:spLocks noGrp="1"/>
-          </p:cNvSpPr>
-          <p:nvPr/>
-        </p:nvSpPr>
-        <p:spPr>
-          <a:xfrm>
-            <a:off x="685800" y="819150"/>
-            <a:ext cx="10287000" cy="685800"/>
-          </a:xfrm>
-          <a:prstGeom prst="rect">
-            <a:avLst/>
-          </a:prstGeom>
-          <a:noFill/>
-          <a:ln w="0">
-            <a:noFill/>
-            <a:prstDash val="solid"/>
-          </a:ln>
-        </p:spPr>
-        <p:txBody>
-          <a:bodyPr/>
-          <a:lstStyle/>
-          <a:p>
-            <a:pPr algn="l">
-              <a:defRPr sz="2850" b="1">
-                <a:solidFill>
-                  <a:srgbClr val="132238"/>
-                </a:solidFill>
-              </a:defRPr>
-            </a:pPr>
-            <a:r>
-              <a:rPr sz="2850" b="1">
-                <a:solidFill>
-                  <a:srgbClr val="132238"/>
-                </a:solidFill>
-              </a:rPr>
-              <a:t>Evaluation proves the MVP and guides next steps</a:t>
-            </a:r>
-          </a:p>
-        </p:txBody>
-      </p:sp>
-      <p:sp>
-        <p:nvSpPr>
-          <p:cNvPr id="3" name="header-rule">
-            <a:extLst>
-              <a:ext uri="{FF2B5EF4-FFF2-40B4-BE49-F238E27FC236}">
-                <a16:creationId xmlns:a16="http://schemas.microsoft.com/office/drawing/2014/main" id="{2D77D10E-48A7-415B-BA45-53466B05BED8}"/>
-              </a:ext>
-            </a:extLst>
-          </p:cNvPr>
-          <p:cNvSpPr>
-            <a:spLocks noGrp="1"/>
-          </p:cNvSpPr>
-          <p:nvPr/>
-        </p:nvSpPr>
-        <p:spPr>
-          <a:xfrm>
-            <a:off x="685800" y="1562100"/>
-            <a:ext cx="10820400" cy="0"/>
-          </a:xfrm>
-          <a:prstGeom prst="line">
-            <a:avLst/>
-          </a:prstGeom>
-          <a:noFill/>
-          <a:ln w="9525">
-            <a:solidFill>
-              <a:srgbClr val="D9E2EC"/>
-            </a:solidFill>
-            <a:prstDash val="solid"/>
-          </a:ln>
-        </p:spPr>
-      </p:sp>
-      <p:sp>
-        <p:nvSpPr>
-          <p:cNvPr id="4" name="footer-5">
-            <a:extLst>
-              <a:ext uri="{FF2B5EF4-FFF2-40B4-BE49-F238E27FC236}">
-                <a16:creationId xmlns:a16="http://schemas.microsoft.com/office/drawing/2014/main" id="{ACBD6796-F9F0-47F8-B7A5-F5F7B6D0A75F}"/>
-              </a:ext>
-            </a:extLst>
-          </p:cNvPr>
-          <p:cNvSpPr>
-            <a:spLocks noGrp="1"/>
-          </p:cNvSpPr>
-          <p:nvPr/>
-        </p:nvSpPr>
-        <p:spPr>
-          <a:xfrm>
-            <a:off x="685800" y="6438900"/>
-            <a:ext cx="4381500" cy="228600"/>
-          </a:xfrm>
-          <a:prstGeom prst="rect">
-            <a:avLst/>
-          </a:prstGeom>
-          <a:noFill/>
-          <a:ln w="0">
-            <a:noFill/>
-            <a:prstDash val="solid"/>
-          </a:ln>
-        </p:spPr>
-        <p:txBody>
-          <a:bodyPr/>
-          <a:lstStyle/>
-          <a:p>
-            <a:pPr algn="l">
-              <a:defRPr sz="900" b="0">
-                <a:solidFill>
-                  <a:srgbClr val="7A8695"/>
-                </a:solidFill>
-              </a:defRPr>
-            </a:pPr>
-            <a:r>
-              <a:rPr sz="900" b="0">
-                <a:solidFill>
-                  <a:srgbClr val="7A8695"/>
-                </a:solidFill>
-              </a:rPr>
-              <a:t>Autonomous AI Agents Case  |  5/5</a:t>
-            </a:r>
-          </a:p>
-        </p:txBody>
-      </p:sp>
-      <p:sp>
-        <p:nvSpPr>
-          <p:cNvPr id="5" name="tests-number">
-            <a:extLst>
-              <a:ext uri="{FF2B5EF4-FFF2-40B4-BE49-F238E27FC236}">
-                <a16:creationId xmlns:a16="http://schemas.microsoft.com/office/drawing/2014/main" id="{0509A4D8-11B5-41FD-9B22-2306B41B9E1C}"/>
-              </a:ext>
-            </a:extLst>
-          </p:cNvPr>
-          <p:cNvSpPr>
-            <a:spLocks noGrp="1"/>
-          </p:cNvSpPr>
-          <p:nvPr/>
-        </p:nvSpPr>
-        <p:spPr>
-          <a:xfrm>
-            <a:off x="819150" y="2133600"/>
-            <a:ext cx="2000250" cy="876300"/>
-          </a:xfrm>
-          <a:prstGeom prst="rect">
-            <a:avLst/>
-          </a:prstGeom>
-          <a:noFill/>
-          <a:ln w="0">
-            <a:noFill/>
-            <a:prstDash val="solid"/>
-          </a:ln>
-        </p:spPr>
-        <p:txBody>
-          <a:bodyPr/>
-          <a:lstStyle/>
-          <a:p>
-            <a:pPr algn="ctr">
-              <a:defRPr sz="5700" b="1">
-                <a:solidFill>
-                  <a:srgbClr val="1F77B4"/>
-                </a:solidFill>
-              </a:defRPr>
-            </a:pPr>
-            <a:r>
-              <a:rPr sz="5700" b="1">
-                <a:solidFill>
-                  <a:srgbClr val="1F77B4"/>
-                </a:solidFill>
-              </a:rPr>
-              <a:t>20/20</a:t>
-            </a:r>
-          </a:p>
-        </p:txBody>
-      </p:sp>
-      <p:sp>
-        <p:nvSpPr>
-          <p:cNvPr id="6" name="tests-label">
-            <a:extLst>
-              <a:ext uri="{FF2B5EF4-FFF2-40B4-BE49-F238E27FC236}">
-                <a16:creationId xmlns:a16="http://schemas.microsoft.com/office/drawing/2014/main" id="{3345D74B-B422-4BB7-94A4-0270E99B60AE}"/>
-              </a:ext>
-            </a:extLst>
-          </p:cNvPr>
-          <p:cNvSpPr>
-            <a:spLocks noGrp="1"/>
-          </p:cNvSpPr>
-          <p:nvPr/>
-        </p:nvSpPr>
-        <p:spPr>
-          <a:xfrm>
-            <a:off x="781050" y="3009900"/>
-            <a:ext cx="2190750" cy="514350"/>
-          </a:xfrm>
-          <a:prstGeom prst="rect">
-            <a:avLst/>
-          </a:prstGeom>
-          <a:noFill/>
-          <a:ln w="0">
-            <a:noFill/>
-            <a:prstDash val="solid"/>
-          </a:ln>
-        </p:spPr>
-        <p:txBody>
-          <a:bodyPr/>
-          <a:lstStyle/>
-          <a:p>
-            <a:pPr algn="ctr">
-              <a:defRPr sz="1650" b="1">
-                <a:solidFill>
-                  <a:srgbClr val="132238"/>
-                </a:solidFill>
-              </a:defRPr>
-            </a:pPr>
-            <a:r>
-              <a:rPr sz="1650" b="1">
-                <a:solidFill>
-                  <a:srgbClr val="132238"/>
-                </a:solidFill>
-              </a:rPr>
-              <a:t>automated tests passing</a:t>
-            </a:r>
-          </a:p>
-        </p:txBody>
-      </p:sp>
-      <p:sp>
-        <p:nvSpPr>
-          <p:cNvPr id="7" name="metric-pass-rate">
-            <a:extLst>
-              <a:ext uri="{FF2B5EF4-FFF2-40B4-BE49-F238E27FC236}">
-                <a16:creationId xmlns:a16="http://schemas.microsoft.com/office/drawing/2014/main" id="{3D073007-05FA-4580-8DBA-D0E5A5B9A79A}"/>
-              </a:ext>
-            </a:extLst>
-          </p:cNvPr>
-          <p:cNvSpPr>
-            <a:spLocks noGrp="1"/>
-          </p:cNvSpPr>
-          <p:nvPr/>
-        </p:nvSpPr>
-        <p:spPr>
-          <a:xfrm>
-            <a:off x="781050" y="3733800"/>
-            <a:ext cx="1790700" cy="723900"/>
-          </a:xfrm>
-          <a:prstGeom prst="roundRect">
-            <a:avLst>
-              <a:gd name="adj" fmla="val 18421"/>
-            </a:avLst>
-          </a:prstGeom>
-          <a:solidFill>
-            <a:srgbClr val="F6F8FB"/>
-          </a:solidFill>
-          <a:ln w="9525">
-            <a:solidFill>
-              <a:srgbClr val="D9E2EC"/>
-            </a:solidFill>
-            <a:prstDash val="solid"/>
-          </a:ln>
-        </p:spPr>
-      </p:sp>
-      <p:sp>
-        <p:nvSpPr>
           <p:cNvPr id="8" name="metric-pass-rate-value">
             <a:extLst>
               <a:ext uri="{FF2B5EF4-FFF2-40B4-BE49-F238E27FC236}">
@@ -7632,6 +5913,7 @@
           <a:lstStyle/>
           <a:p>
             <a:pPr algn="ctr">
+              <a:buNone/>
               <a:defRPr sz="1950" b="1">
                 <a:solidFill>
                   <a:srgbClr val="FF7F0E"/>
@@ -7682,6 +5964,7 @@
           <a:lstStyle/>
           <a:p>
             <a:pPr algn="ctr">
+              <a:buNone/>
               <a:defRPr sz="975" b="0">
                 <a:solidFill>
                   <a:srgbClr val="5E6B7A"/>
@@ -7689,147 +5972,12 @@
               </a:defRPr>
             </a:pPr>
             <a:r>
-              <a:rPr sz="975" b="0">
+              <a:rPr sz="975" b="0" dirty="0">
                 <a:solidFill>
                   <a:srgbClr val="5E6B7A"/>
                 </a:solidFill>
               </a:rPr>
-              <a:t>local pass rate</a:t>
-            </a:r>
-          </a:p>
-        </p:txBody>
-      </p:sp>
-      <p:sp>
-        <p:nvSpPr>
-          <p:cNvPr id="10" name="metric-risk">
-            <a:extLst>
-              <a:ext uri="{FF2B5EF4-FFF2-40B4-BE49-F238E27FC236}">
-                <a16:creationId xmlns:a16="http://schemas.microsoft.com/office/drawing/2014/main" id="{0AF3B6B7-5C9F-404C-8933-F56D031DB315}"/>
-              </a:ext>
-            </a:extLst>
-          </p:cNvPr>
-          <p:cNvSpPr>
-            <a:spLocks noGrp="1"/>
-          </p:cNvSpPr>
-          <p:nvPr/>
-        </p:nvSpPr>
-        <p:spPr>
-          <a:xfrm>
-            <a:off x="781050" y="4629150"/>
-            <a:ext cx="1790700" cy="723900"/>
-          </a:xfrm>
-          <a:prstGeom prst="roundRect">
-            <a:avLst>
-              <a:gd name="adj" fmla="val 18421"/>
-            </a:avLst>
-          </a:prstGeom>
-          <a:solidFill>
-            <a:srgbClr val="F6F8FB"/>
-          </a:solidFill>
-          <a:ln w="9525">
-            <a:solidFill>
-              <a:srgbClr val="D9E2EC"/>
-            </a:solidFill>
-            <a:prstDash val="solid"/>
-          </a:ln>
-        </p:spPr>
-      </p:sp>
-      <p:sp>
-        <p:nvSpPr>
-          <p:cNvPr id="11" name="metric-risk-value">
-            <a:extLst>
-              <a:ext uri="{FF2B5EF4-FFF2-40B4-BE49-F238E27FC236}">
-                <a16:creationId xmlns:a16="http://schemas.microsoft.com/office/drawing/2014/main" id="{2F4CACEB-ABBD-4A43-8147-34F88116A2CC}"/>
-              </a:ext>
-            </a:extLst>
-          </p:cNvPr>
-          <p:cNvSpPr>
-            <a:spLocks noGrp="1"/>
-          </p:cNvSpPr>
-          <p:nvPr/>
-        </p:nvSpPr>
-        <p:spPr>
-          <a:xfrm>
-            <a:off x="933450" y="4762500"/>
-            <a:ext cx="1485900" cy="285750"/>
-          </a:xfrm>
-          <a:prstGeom prst="rect">
-            <a:avLst/>
-          </a:prstGeom>
-          <a:noFill/>
-          <a:ln w="0">
-            <a:noFill/>
-            <a:prstDash val="solid"/>
-          </a:ln>
-        </p:spPr>
-        <p:txBody>
-          <a:bodyPr/>
-          <a:lstStyle/>
-          <a:p>
-            <a:pPr algn="ctr">
-              <a:defRPr sz="1950" b="1">
-                <a:solidFill>
-                  <a:srgbClr val="FF7F0E"/>
-                </a:solidFill>
-              </a:defRPr>
-            </a:pPr>
-            <a:r>
-              <a:rPr sz="1950" b="1">
-                <a:solidFill>
-                  <a:srgbClr val="FF7F0E"/>
-                </a:solidFill>
-              </a:rPr>
-              <a:t>6</a:t>
-            </a:r>
-          </a:p>
-        </p:txBody>
-      </p:sp>
-      <p:sp>
-        <p:nvSpPr>
-          <p:cNvPr id="12" name="metric-risk-label">
-            <a:extLst>
-              <a:ext uri="{FF2B5EF4-FFF2-40B4-BE49-F238E27FC236}">
-                <a16:creationId xmlns:a16="http://schemas.microsoft.com/office/drawing/2014/main" id="{E0359E40-211B-4035-B419-3675496C41DD}"/>
-              </a:ext>
-            </a:extLst>
-          </p:cNvPr>
-          <p:cNvSpPr>
-            <a:spLocks noGrp="1"/>
-          </p:cNvSpPr>
-          <p:nvPr/>
-        </p:nvSpPr>
-        <p:spPr>
-          <a:xfrm>
-            <a:off x="952500" y="5067300"/>
-            <a:ext cx="1447800" cy="209550"/>
-          </a:xfrm>
-          <a:prstGeom prst="rect">
-            <a:avLst/>
-          </a:prstGeom>
-          <a:noFill/>
-          <a:ln w="0">
-            <a:noFill/>
-            <a:prstDash val="solid"/>
-          </a:ln>
-        </p:spPr>
-        <p:txBody>
-          <a:bodyPr/>
-          <a:lstStyle/>
-          <a:p>
-            <a:pPr algn="ctr">
-              <a:defRPr sz="975" b="0">
-                <a:solidFill>
-                  <a:srgbClr val="5E6B7A"/>
-                </a:solidFill>
-              </a:defRPr>
-            </a:pPr>
-            <a:r>
-              <a:rPr sz="975" b="0">
-                <a:solidFill>
-                  <a:srgbClr val="5E6B7A"/>
-                </a:solidFill>
-              </a:rPr>
-              <a:t>risk areas covered</a:t>
+              <a:t>pass rate</a:t>
             </a:r>
           </a:p>
         </p:txBody>
@@ -7900,6 +6048,7 @@
           <a:lstStyle/>
           <a:p>
             <a:pPr algn="l">
+              <a:buNone/>
               <a:defRPr sz="1800" b="1">
                 <a:solidFill>
                   <a:srgbClr val="132238"/>
@@ -7981,6 +6130,7 @@
           <a:lstStyle/>
           <a:p>
             <a:pPr algn="l">
+              <a:buNone/>
               <a:defRPr sz="1275" b="0">
                 <a:solidFill>
                   <a:srgbClr val="132238"/>
@@ -7988,12 +6138,20 @@
               </a:defRPr>
             </a:pPr>
             <a:r>
-              <a:rPr sz="1275" b="0" dirty="0">
+              <a:rPr sz="1275" b="1" u="sng" dirty="0">
                 <a:solidFill>
                   <a:srgbClr val="132238"/>
                 </a:solidFill>
               </a:rPr>
-              <a:t>User access: allowed, blocked, created, updated, unchanged</a:t>
+              <a:t>User access</a:t>
+            </a:r>
+            <a:r>
+              <a:rPr sz="1275" b="1" dirty="0">
+                <a:solidFill>
+                  <a:srgbClr val="132238"/>
+                </a:solidFill>
+              </a:rPr>
+              <a:t>: allowed, blocked, created, updated</a:t>
             </a:r>
           </a:p>
         </p:txBody>
@@ -8062,6 +6220,7 @@
           <a:lstStyle/>
           <a:p>
             <a:pPr algn="l">
+              <a:buNone/>
               <a:defRPr sz="1275" b="0">
                 <a:solidFill>
                   <a:srgbClr val="132238"/>
@@ -8069,12 +6228,20 @@
               </a:defRPr>
             </a:pPr>
             <a:r>
-              <a:rPr sz="1275" b="0">
+              <a:rPr sz="1275" b="1" u="sng" dirty="0">
                 <a:solidFill>
                   <a:srgbClr val="132238"/>
                 </a:solidFill>
               </a:rPr>
-              <a:t>Easy integration: add DB config, validate SQLite, grant access</a:t>
+              <a:t>Easy integration</a:t>
+            </a:r>
+            <a:r>
+              <a:rPr sz="1275" b="1" dirty="0">
+                <a:solidFill>
+                  <a:srgbClr val="132238"/>
+                </a:solidFill>
+              </a:rPr>
+              <a:t>: add DB, validate SQLite, grant users</a:t>
             </a:r>
           </a:p>
         </p:txBody>
@@ -8143,6 +6310,7 @@
           <a:lstStyle/>
           <a:p>
             <a:pPr algn="l">
+              <a:buNone/>
               <a:defRPr sz="1275" b="0">
                 <a:solidFill>
                   <a:srgbClr val="132238"/>
@@ -8150,12 +6318,20 @@
               </a:defRPr>
             </a:pPr>
             <a:r>
-              <a:rPr sz="1275" b="0">
+              <a:rPr sz="1275" b="1" u="sng" dirty="0">
                 <a:solidFill>
                   <a:srgbClr val="132238"/>
                 </a:solidFill>
               </a:rPr>
-              <a:t>Database layer: registry lookup, schema reading, read-only query</a:t>
+              <a:t>Database layer</a:t>
+            </a:r>
+            <a:r>
+              <a:rPr sz="1275" b="1" dirty="0">
+                <a:solidFill>
+                  <a:srgbClr val="132238"/>
+                </a:solidFill>
+              </a:rPr>
+              <a:t>: registry lookup, schema read, read-only query</a:t>
             </a:r>
           </a:p>
         </p:txBody>
@@ -8224,6 +6400,7 @@
           <a:lstStyle/>
           <a:p>
             <a:pPr algn="l">
+              <a:buNone/>
               <a:defRPr sz="1275" b="0">
                 <a:solidFill>
                   <a:srgbClr val="132238"/>
@@ -8231,12 +6408,20 @@
               </a:defRPr>
             </a:pPr>
             <a:r>
-              <a:rPr sz="1275" b="0">
+              <a:rPr sz="1275" b="1" u="sng" dirty="0">
                 <a:solidFill>
                   <a:srgbClr val="132238"/>
                 </a:solidFill>
               </a:rPr>
-              <a:t>SQL safety: mutation SQL blocked, LIMIT enforced</a:t>
+              <a:t>SQL safety</a:t>
+            </a:r>
+            <a:r>
+              <a:rPr sz="1275" b="1" dirty="0">
+                <a:solidFill>
+                  <a:srgbClr val="132238"/>
+                </a:solidFill>
+              </a:rPr>
+              <a:t>: mutation SQL blocked, LIMIT enforced</a:t>
             </a:r>
           </a:p>
         </p:txBody>
@@ -8305,6 +6490,7 @@
           <a:lstStyle/>
           <a:p>
             <a:pPr algn="l">
+              <a:buNone/>
               <a:defRPr sz="1275" b="0">
                 <a:solidFill>
                   <a:srgbClr val="132238"/>
@@ -8312,12 +6498,20 @@
               </a:defRPr>
             </a:pPr>
             <a:r>
-              <a:rPr sz="1275" b="0">
+              <a:rPr sz="1275" b="1" u="sng" dirty="0">
                 <a:solidFill>
                   <a:srgbClr val="132238"/>
                 </a:solidFill>
               </a:rPr>
-              <a:t>Analysis agent: row limits, irrelevant questions, exact offline samples</a:t>
+              <a:t>Analysis agent</a:t>
+            </a:r>
+            <a:r>
+              <a:rPr sz="1275" b="1" dirty="0">
+                <a:solidFill>
+                  <a:srgbClr val="132238"/>
+                </a:solidFill>
+              </a:rPr>
+              <a:t>: row limits, invalid questions, offline samples</a:t>
             </a:r>
           </a:p>
         </p:txBody>
@@ -8386,6 +6580,7 @@
           <a:lstStyle/>
           <a:p>
             <a:pPr algn="l">
+              <a:buNone/>
               <a:defRPr sz="1275" b="0">
                 <a:solidFill>
                   <a:srgbClr val="132238"/>
@@ -8393,179 +6588,36 @@
               </a:defRPr>
             </a:pPr>
             <a:r>
-              <a:rPr sz="1275" b="0">
+              <a:rPr sz="1275" b="1" u="sng" dirty="0">
                 <a:solidFill>
                   <a:srgbClr val="132238"/>
                 </a:solidFill>
               </a:rPr>
-              <a:t>Visualization + pipeline: chart/CSV output and two-agent handoff</a:t>
-            </a:r>
-          </a:p>
-        </p:txBody>
-      </p:sp>
-      <p:sp>
-        <p:nvSpPr>
-          <p:cNvPr id="27" name="accent-Quality checks">
-            <a:extLst>
-              <a:ext uri="{FF2B5EF4-FFF2-40B4-BE49-F238E27FC236}">
-                <a16:creationId xmlns:a16="http://schemas.microsoft.com/office/drawing/2014/main" id="{5D172181-3C8E-479E-89E1-659887AEFEDB}"/>
-              </a:ext>
-            </a:extLst>
-          </p:cNvPr>
-          <p:cNvSpPr>
-            <a:spLocks noGrp="1"/>
-          </p:cNvSpPr>
-          <p:nvPr/>
-        </p:nvSpPr>
-        <p:spPr>
-          <a:xfrm>
-            <a:off x="3333750" y="5257800"/>
-            <a:ext cx="47625" cy="323850"/>
-          </a:xfrm>
-          <a:prstGeom prst="rect">
-            <a:avLst/>
-          </a:prstGeom>
-          <a:solidFill>
-            <a:srgbClr val="FF7F0E"/>
-          </a:solidFill>
-          <a:ln w="0">
-            <a:solidFill>
-              <a:srgbClr val="FF7F0E"/>
-            </a:solidFill>
-            <a:prstDash val="solid"/>
-          </a:ln>
-        </p:spPr>
-      </p:sp>
-      <p:sp>
-        <p:nvSpPr>
-          <p:cNvPr id="28" name="label-Quality checks">
-            <a:extLst>
-              <a:ext uri="{FF2B5EF4-FFF2-40B4-BE49-F238E27FC236}">
-                <a16:creationId xmlns:a16="http://schemas.microsoft.com/office/drawing/2014/main" id="{A8E64DEA-BB2A-4005-9186-E36C50336D33}"/>
-              </a:ext>
-            </a:extLst>
-          </p:cNvPr>
-          <p:cNvSpPr>
-            <a:spLocks noGrp="1"/>
-          </p:cNvSpPr>
-          <p:nvPr/>
-        </p:nvSpPr>
-        <p:spPr>
-          <a:xfrm>
-            <a:off x="3486150" y="5219700"/>
-            <a:ext cx="2952750" cy="419100"/>
-          </a:xfrm>
-          <a:prstGeom prst="rect">
-            <a:avLst/>
-          </a:prstGeom>
-          <a:noFill/>
-          <a:ln w="0">
-            <a:noFill/>
-            <a:prstDash val="solid"/>
-          </a:ln>
-        </p:spPr>
-        <p:txBody>
-          <a:bodyPr/>
-          <a:lstStyle/>
-          <a:p>
-            <a:pPr algn="l">
-              <a:defRPr sz="1800" b="1">
+              <a:t>SQL eval</a:t>
+            </a:r>
+            <a:r>
+              <a:rPr sz="1275" b="1" dirty="0">
                 <a:solidFill>
                   <a:srgbClr val="132238"/>
                 </a:solidFill>
-              </a:defRPr>
-            </a:pPr>
-            <a:r>
-              <a:rPr sz="1800" b="1">
+              </a:rPr>
+              <a:t>: </a:t>
+            </a:r>
+            <a:r>
+              <a:rPr sz="1275" b="1" dirty="0" err="1">
                 <a:solidFill>
                   <a:srgbClr val="132238"/>
                 </a:solidFill>
               </a:rPr>
-              <a:t>Quality checks</a:t>
-            </a:r>
-          </a:p>
-        </p:txBody>
-      </p:sp>
-      <p:sp>
-        <p:nvSpPr>
-          <p:cNvPr id="29" name="quality-checks">
-            <a:extLst>
-              <a:ext uri="{FF2B5EF4-FFF2-40B4-BE49-F238E27FC236}">
-                <a16:creationId xmlns:a16="http://schemas.microsoft.com/office/drawing/2014/main" id="{A5CE4614-682A-4258-9FB8-AD7289981F1F}"/>
-              </a:ext>
-            </a:extLst>
-          </p:cNvPr>
-          <p:cNvSpPr>
-            <a:spLocks noGrp="1"/>
-          </p:cNvSpPr>
-          <p:nvPr/>
-        </p:nvSpPr>
-        <p:spPr>
-          <a:xfrm>
-            <a:off x="3486150" y="5638800"/>
-            <a:ext cx="3733800" cy="628650"/>
-          </a:xfrm>
-          <a:prstGeom prst="rect">
-            <a:avLst/>
-          </a:prstGeom>
-          <a:noFill/>
-          <a:ln w="0">
-            <a:noFill/>
-            <a:prstDash val="solid"/>
-          </a:ln>
-        </p:spPr>
-        <p:txBody>
-          <a:bodyPr/>
-          <a:lstStyle/>
-          <a:p>
-            <a:pPr algn="l">
-              <a:defRPr sz="1200" b="0">
-                <a:solidFill>
-                  <a:srgbClr val="5E6B7A"/>
-                </a:solidFill>
-              </a:defRPr>
-            </a:pPr>
-            <a:r>
-              <a:rPr sz="1200" b="0">
-                <a:solidFill>
-                  <a:srgbClr val="5E6B7A"/>
-                </a:solidFill>
-              </a:rPr>
-              <a:t>Correct outputs: expected rows, columns, files</a:t>
-            </a:r>
-          </a:p>
-          <a:p>
-            <a:pPr algn="l">
-              <a:defRPr sz="1200" b="0">
-                <a:solidFill>
-                  <a:srgbClr val="5E6B7A"/>
-                </a:solidFill>
-              </a:defRPr>
-            </a:pPr>
-            <a:r>
-              <a:rPr sz="1200" b="0">
-                <a:solidFill>
-                  <a:srgbClr val="5E6B7A"/>
-                </a:solidFill>
-              </a:rPr>
-              <a:t>Controlled risk: blocked unsafe SQL and denied access</a:t>
-            </a:r>
-          </a:p>
-          <a:p>
-            <a:pPr algn="l">
-              <a:defRPr sz="1200" b="0">
-                <a:solidFill>
-                  <a:srgbClr val="5E6B7A"/>
-                </a:solidFill>
-              </a:defRPr>
-            </a:pPr>
-            <a:r>
-              <a:rPr sz="1200" b="0">
-                <a:solidFill>
-                  <a:srgbClr val="5E6B7A"/>
-                </a:solidFill>
-              </a:rPr>
-              <a:t>Integration path: new DB + user tested end to end</a:t>
+              <a:t>pytest</a:t>
+            </a:r>
+            <a:r>
+              <a:rPr sz="1275" b="1" dirty="0">
+                <a:solidFill>
+                  <a:srgbClr val="132238"/>
+                </a:solidFill>
+              </a:rPr>
+              <a:t> covers logic; online LLM eval runs separately</a:t>
             </a:r>
           </a:p>
         </p:txBody>
@@ -8636,6 +6688,7 @@
           <a:lstStyle/>
           <a:p>
             <a:pPr algn="l">
+              <a:buNone/>
               <a:defRPr sz="1800" b="1">
                 <a:solidFill>
                   <a:srgbClr val="132238"/>
@@ -8686,6 +6739,7 @@
           <a:lstStyle/>
           <a:p>
             <a:pPr algn="l">
+              <a:buNone/>
               <a:defRPr sz="1200" b="0">
                 <a:solidFill>
                   <a:srgbClr val="5E6B7A"/>
@@ -8698,11 +6752,12 @@
                   <a:srgbClr val="5E6B7A"/>
                 </a:solidFill>
               </a:rPr>
-              <a:t>Golden SQL/result benchmark</a:t>
+              <a:t>Expand SQL/result benchmark</a:t>
             </a:r>
           </a:p>
           <a:p>
             <a:pPr algn="l">
+              <a:buNone/>
               <a:defRPr sz="1200" b="0">
                 <a:solidFill>
                   <a:srgbClr val="5E6B7A"/>
@@ -8720,6 +6775,7 @@
           </a:p>
           <a:p>
             <a:pPr algn="l">
+              <a:buNone/>
               <a:defRPr sz="1200" b="0">
                 <a:solidFill>
                   <a:srgbClr val="5E6B7A"/>
@@ -8737,6 +6793,7 @@
           </a:p>
           <a:p>
             <a:pPr algn="l">
+              <a:buNone/>
               <a:defRPr sz="1200" b="0">
                 <a:solidFill>
                   <a:srgbClr val="5E6B7A"/>

</xml_diff>